<commit_message>
Phase 6: embed all 6 fallback screenshots in deck, fix mislabeled backup slides
All 6 screenshots in demo/fallback/SCREENSHOTS_TO_TAKE.md are now captured and
embedded in Presales_Deck.pptx (6 visible + 10 hidden backup slides), each
verified against RESULTS.md. Fixed 2 backup slides left with generic titles
and a stale "Executive page" caption copy-pasted from the loop that embedded
them. Updated README and the screenshot checklist to match.

Co-Authored-By: Claude Sonnet 5 <noreply@anthropic.com>
</commit_message>
<xml_diff>
--- a/deck/Presales_Deck.pptx
+++ b/deck/Presales_Deck.pptx
@@ -4,6 +4,9 @@
   <p:sldMasterIdLst>
     <p:sldMasterId id="2147483648" r:id="rId1"/>
   </p:sldMasterIdLst>
+  <p:notesMasterIdLst>
+    <p:notesMasterId r:id="rId18"/>
+  </p:notesMasterIdLst>
   <p:sldIdLst>
     <p:sldId id="256" r:id="rId2"/>
     <p:sldId id="257" r:id="rId3"/>
@@ -15,15 +18,14 @@
     <p:sldId id="263" r:id="rId9"/>
     <p:sldId id="264" r:id="rId10"/>
     <p:sldId id="265" r:id="rId11"/>
-    <p:sldId id="266" r:id="rId12"/>
-    <p:sldId id="267" r:id="rId13"/>
-    <p:sldId id="268" r:id="rId14"/>
-    <p:sldId id="269" r:id="rId15"/>
+    <p:sldId id="270" r:id="rId12"/>
+    <p:sldId id="271" r:id="rId13"/>
+    <p:sldId id="266" r:id="rId14"/>
+    <p:sldId id="267" r:id="rId15"/>
+    <p:sldId id="268" r:id="rId16"/>
+    <p:sldId id="269" r:id="rId17"/>
   </p:sldIdLst>
-  <p:notesMasterIdLst>
-    <p:notesMasterId r:id="rId16"/>
-  </p:notesMasterIdLst>
-  <p:sldSz cx="9144000" cy="5143500"/>
+  <p:sldSz cx="9144000" cy="5143500" type="screen16x9"/>
   <p:notesSz cx="5143500" cy="9144000"/>
   <p:defaultTextStyle>
     <a:lvl1pPr marL="0" algn="l" defTabSz="914400" rtl="0" eaLnBrk="1" latinLnBrk="0" hangingPunct="1">
@@ -117,6 +119,11 @@
       </a:defRPr>
     </a:lvl9pPr>
   </p:defaultTextStyle>
+  <p:extLst>
+    <p:ext uri="{EFAFB233-063F-42B5-8137-9DF3F51BA10A}">
+      <p15:sldGuideLst xmlns:p15="http://schemas.microsoft.com/office/powerpoint/2012/main"/>
+    </p:ext>
+  </p:extLst>
 </p:presentation>
 </file>
 
@@ -142,234 +149,10 @@
           <a:chExt cx="0" cy="0"/>
         </a:xfrm>
       </p:grpSpPr>
-      <p:sp>
-        <p:nvSpPr>
-          <p:cNvPr id="2" name="Header Placeholder 1"/>
-          <p:cNvSpPr>
-            <a:spLocks noGrp="1"/>
-          </p:cNvSpPr>
-          <p:nvPr>
-            <p:ph type="hdr" sz="quarter"/>
-          </p:nvPr>
-        </p:nvSpPr>
-        <p:spPr>
-          <a:xfrm>
-            <a:off x="0" y="0"/>
-            <a:ext cx="2971800" cy="458788"/>
-          </a:xfrm>
-          <a:prstGeom prst="rect">
-            <a:avLst/>
-          </a:prstGeom>
-        </p:spPr>
-        <p:txBody>
-          <a:bodyPr vert="horz" lIns="91440" tIns="45720" rIns="91440" bIns="45720" rtlCol="0"/>
-          <a:lstStyle>
-            <a:lvl1pPr algn="l">
-              <a:defRPr sz="1200"/>
-            </a:lvl1pPr>
-          </a:lstStyle>
-          <a:p>
-            <a:endParaRPr lang="en-US"/>
-          </a:p>
-        </p:txBody>
-      </p:sp>
-      <p:sp>
-        <p:nvSpPr>
-          <p:cNvPr id="3" name="Date Placeholder 2"/>
-          <p:cNvSpPr>
-            <a:spLocks noGrp="1"/>
-          </p:cNvSpPr>
-          <p:nvPr>
-            <p:ph type="dt" idx="1"/>
-          </p:nvPr>
-        </p:nvSpPr>
-        <p:spPr>
-          <a:xfrm>
-            <a:off x="3884613" y="0"/>
-            <a:ext cx="2971800" cy="458788"/>
-          </a:xfrm>
-          <a:prstGeom prst="rect">
-            <a:avLst/>
-          </a:prstGeom>
-        </p:spPr>
-        <p:txBody>
-          <a:bodyPr vert="horz" lIns="91440" tIns="45720" rIns="91440" bIns="45720" rtlCol="0"/>
-          <a:lstStyle>
-            <a:lvl1pPr algn="r">
-              <a:defRPr sz="1200"/>
-            </a:lvl1pPr>
-          </a:lstStyle>
-          <a:p>
-            <a:fld id="{5282F153-3F37-0F45-9E97-73ACFA13230C}" type="datetimeFigureOut">
-              <a:rPr lang="en-US"/>
-              <a:t>7/23/19</a:t>
-            </a:fld>
-            <a:endParaRPr lang="en-US"/>
-          </a:p>
-        </p:txBody>
-      </p:sp>
-      <p:sp>
-        <p:nvSpPr>
-          <p:cNvPr id="4" name="Slide Image Placeholder 3"/>
-          <p:cNvSpPr>
-            <a:spLocks noGrp="1" noRot="1" noChangeAspect="1"/>
-          </p:cNvSpPr>
-          <p:nvPr>
-            <p:ph type="sldImg" idx="2"/>
-          </p:nvPr>
-        </p:nvSpPr>
-        <p:spPr>
-          <a:xfrm>
-            <a:off x="685800" y="1143000"/>
-            <a:ext cx="5486400" cy="3086100"/>
-          </a:xfrm>
-          <a:prstGeom prst="rect">
-            <a:avLst/>
-          </a:prstGeom>
-          <a:noFill/>
-          <a:ln w="12700">
-            <a:solidFill>
-              <a:prstClr val="black"/>
-            </a:solidFill>
-          </a:ln>
-        </p:spPr>
-        <p:txBody>
-          <a:bodyPr vert="horz" lIns="91440" tIns="45720" rIns="91440" bIns="45720" rtlCol="0" anchor="ctr"/>
-          <a:lstStyle/>
-          <a:p>
-            <a:endParaRPr lang="en-US"/>
-          </a:p>
-        </p:txBody>
-      </p:sp>
-      <p:sp>
-        <p:nvSpPr>
-          <p:cNvPr id="5" name="Notes Placeholder 4"/>
-          <p:cNvSpPr>
-            <a:spLocks noGrp="1"/>
-          </p:cNvSpPr>
-          <p:nvPr>
-            <p:ph type="body" sz="quarter" idx="3"/>
-          </p:nvPr>
-        </p:nvSpPr>
-        <p:spPr>
-          <a:xfrm>
-            <a:off x="685800" y="4400550"/>
-            <a:ext cx="5486400" cy="3600450"/>
-          </a:xfrm>
-          <a:prstGeom prst="rect">
-            <a:avLst/>
-          </a:prstGeom>
-        </p:spPr>
-        <p:txBody>
-          <a:bodyPr vert="horz" lIns="91440" tIns="45720" rIns="91440" bIns="45720" rtlCol="0"/>
-          <a:lstStyle/>
-          <a:p>
-            <a:pPr lvl="0"/>
-            <a:r>
-              <a:rPr lang="en-US"/>
-              <a:t>Click to edit Master text styles</a:t>
-            </a:r>
-          </a:p>
-          <a:p>
-            <a:pPr lvl="1"/>
-            <a:r>
-              <a:rPr lang="en-US"/>
-              <a:t>Second level</a:t>
-            </a:r>
-          </a:p>
-          <a:p>
-            <a:pPr lvl="2"/>
-            <a:r>
-              <a:rPr lang="en-US"/>
-              <a:t>Third level</a:t>
-            </a:r>
-          </a:p>
-          <a:p>
-            <a:pPr lvl="3"/>
-            <a:r>
-              <a:rPr lang="en-US"/>
-              <a:t>Fourth level</a:t>
-            </a:r>
-          </a:p>
-          <a:p>
-            <a:pPr lvl="4"/>
-            <a:r>
-              <a:rPr lang="en-US"/>
-              <a:t>Fifth level</a:t>
-            </a:r>
-          </a:p>
-        </p:txBody>
-      </p:sp>
-      <p:sp>
-        <p:nvSpPr>
-          <p:cNvPr id="6" name="Footer Placeholder 5"/>
-          <p:cNvSpPr>
-            <a:spLocks noGrp="1"/>
-          </p:cNvSpPr>
-          <p:nvPr>
-            <p:ph type="ftr" sz="quarter" idx="4"/>
-          </p:nvPr>
-        </p:nvSpPr>
-        <p:spPr>
-          <a:xfrm>
-            <a:off x="0" y="8685213"/>
-            <a:ext cx="2971800" cy="458787"/>
-          </a:xfrm>
-          <a:prstGeom prst="rect">
-            <a:avLst/>
-          </a:prstGeom>
-        </p:spPr>
-        <p:txBody>
-          <a:bodyPr vert="horz" lIns="91440" tIns="45720" rIns="91440" bIns="45720" rtlCol="0" anchor="b"/>
-          <a:lstStyle>
-            <a:lvl1pPr algn="l">
-              <a:defRPr sz="1200"/>
-            </a:lvl1pPr>
-          </a:lstStyle>
-          <a:p>
-            <a:endParaRPr lang="en-US"/>
-          </a:p>
-        </p:txBody>
-      </p:sp>
-      <p:sp>
-        <p:nvSpPr>
-          <p:cNvPr id="7" name="Slide Number Placeholder 6"/>
-          <p:cNvSpPr>
-            <a:spLocks noGrp="1"/>
-          </p:cNvSpPr>
-          <p:nvPr>
-            <p:ph type="sldNum" sz="quarter" idx="5"/>
-          </p:nvPr>
-        </p:nvSpPr>
-        <p:spPr>
-          <a:xfrm>
-            <a:off x="3884613" y="8685213"/>
-            <a:ext cx="2971800" cy="458787"/>
-          </a:xfrm>
-          <a:prstGeom prst="rect">
-            <a:avLst/>
-          </a:prstGeom>
-        </p:spPr>
-        <p:txBody>
-          <a:bodyPr vert="horz" lIns="91440" tIns="45720" rIns="91440" bIns="45720" rtlCol="0" anchor="b"/>
-          <a:lstStyle>
-            <a:lvl1pPr algn="r">
-              <a:defRPr sz="1200"/>
-            </a:lvl1pPr>
-          </a:lstStyle>
-          <a:p>
-            <a:fld id="{CE5E9CC1-C706-0F49-92D6-E571CC5EEA8F}" type="slidenum">
-              <a:rPr lang="en-US"/>
-              <a:t>‹#›</a:t>
-            </a:fld>
-            <a:endParaRPr lang="en-US"/>
-          </a:p>
-        </p:txBody>
-      </p:sp>
     </p:spTree>
     <p:extLst>
       <p:ext uri="{BB962C8B-B14F-4D97-AF65-F5344CB8AC3E}">
-        <p14:creationId xmlns:p14="http://schemas.microsoft.com/office/powerpoint/2010/main" val="1024086991"/>
+        <p14:creationId xmlns:p14="http://schemas.microsoft.com/office/powerpoint/2010/main" val="3804321970"/>
       </p:ext>
     </p:extLst>
   </p:cSld>
@@ -522,7 +305,6 @@
 BRIDGE: "Before I show anything, I want to confirm I understood each of you."
 CLOCK: whole meeting is 45 min role-play + 15 min debrief. Plan 25 min of content; questions will fill the rest.</a:t>
             </a:r>
-            <a:endParaRPr lang="en-US" dirty="0"/>
           </a:p>
         </p:txBody>
       </p:sp>
@@ -610,7 +392,6 @@
               <a:rPr lang="en-US" dirty="0"/>
               <a:t>BACKUP (hidden). Fallback if the live demo fails. Say what it proves in one sentence.</a:t>
             </a:r>
-            <a:endParaRPr lang="en-US" dirty="0"/>
           </a:p>
         </p:txBody>
       </p:sp>
@@ -655,7 +436,13 @@
   <p:cSld>
     <p:spTree>
       <p:nvGrpSpPr>
-        <p:cNvPr id="1" name=""/>
+        <p:cNvPr id="1" name="">
+          <a:extLst>
+            <a:ext uri="{FF2B5EF4-FFF2-40B4-BE49-F238E27FC236}">
+              <a16:creationId xmlns:a16="http://schemas.microsoft.com/office/drawing/2014/main" id="{8EC3474E-3917-9937-FC79-128C628D88D3}"/>
+            </a:ext>
+          </a:extLst>
+        </p:cNvPr>
         <p:cNvGrpSpPr/>
         <p:nvPr/>
       </p:nvGrpSpPr>
@@ -669,7 +456,13 @@
       </p:grpSpPr>
       <p:sp>
         <p:nvSpPr>
-          <p:cNvPr id="2" name="Slide Image Placeholder 1"/>
+          <p:cNvPr id="2" name="Slide Image Placeholder 1">
+            <a:extLst>
+              <a:ext uri="{FF2B5EF4-FFF2-40B4-BE49-F238E27FC236}">
+                <a16:creationId xmlns:a16="http://schemas.microsoft.com/office/drawing/2014/main" id="{04D06609-3944-9F1E-FF74-2D6352B6F9CA}"/>
+              </a:ext>
+            </a:extLst>
+          </p:cNvPr>
           <p:cNvSpPr>
             <a:spLocks noGrp="1" noRot="1" noChangeAspect="1"/>
           </p:cNvSpPr>
@@ -681,7 +474,13 @@
       </p:sp>
       <p:sp>
         <p:nvSpPr>
-          <p:cNvPr id="3" name="Notes Placeholder 2"/>
+          <p:cNvPr id="3" name="Notes Placeholder 2">
+            <a:extLst>
+              <a:ext uri="{FF2B5EF4-FFF2-40B4-BE49-F238E27FC236}">
+                <a16:creationId xmlns:a16="http://schemas.microsoft.com/office/drawing/2014/main" id="{62F0E3AC-964C-E796-5DF0-ACCC59909D29}"/>
+              </a:ext>
+            </a:extLst>
+          </p:cNvPr>
           <p:cNvSpPr>
             <a:spLocks noGrp="1"/>
           </p:cNvSpPr>
@@ -698,13 +497,18 @@
               <a:rPr lang="en-US" dirty="0"/>
               <a:t>BACKUP (hidden). Fallback if the live demo fails. Say what it proves in one sentence.</a:t>
             </a:r>
-            <a:endParaRPr lang="en-US" dirty="0"/>
-          </a:p>
-        </p:txBody>
-      </p:sp>
-      <p:sp>
-        <p:nvSpPr>
-          <p:cNvPr id="4" name="Slide Number Placeholder 3"/>
+          </a:p>
+        </p:txBody>
+      </p:sp>
+      <p:sp>
+        <p:nvSpPr>
+          <p:cNvPr id="4" name="Slide Number Placeholder 3">
+            <a:extLst>
+              <a:ext uri="{FF2B5EF4-FFF2-40B4-BE49-F238E27FC236}">
+                <a16:creationId xmlns:a16="http://schemas.microsoft.com/office/drawing/2014/main" id="{0EFBEC6A-0003-5F0D-8456-3DC09330A6DD}"/>
+              </a:ext>
+            </a:extLst>
+          </p:cNvPr>
           <p:cNvSpPr>
             <a:spLocks noGrp="1"/>
           </p:cNvSpPr>
@@ -728,7 +532,7 @@
     </p:spTree>
     <p:extLst>
       <p:ext uri="{BB962C8B-B14F-4D97-AF65-F5344CB8AC3E}">
-        <p14:creationId xmlns:p14="http://schemas.microsoft.com/office/powerpoint/2010/main" val="1024086991"/>
+        <p14:creationId xmlns:p14="http://schemas.microsoft.com/office/powerpoint/2010/main" val="115464852"/>
       </p:ext>
     </p:extLst>
   </p:cSld>
@@ -743,7 +547,13 @@
   <p:cSld>
     <p:spTree>
       <p:nvGrpSpPr>
-        <p:cNvPr id="1" name=""/>
+        <p:cNvPr id="1" name="">
+          <a:extLst>
+            <a:ext uri="{FF2B5EF4-FFF2-40B4-BE49-F238E27FC236}">
+              <a16:creationId xmlns:a16="http://schemas.microsoft.com/office/drawing/2014/main" id="{6055EE5D-A3FB-924F-1D1B-516B947E7309}"/>
+            </a:ext>
+          </a:extLst>
+        </p:cNvPr>
         <p:cNvGrpSpPr/>
         <p:nvPr/>
       </p:nvGrpSpPr>
@@ -757,7 +567,13 @@
       </p:grpSpPr>
       <p:sp>
         <p:nvSpPr>
-          <p:cNvPr id="2" name="Slide Image Placeholder 1"/>
+          <p:cNvPr id="2" name="Slide Image Placeholder 1">
+            <a:extLst>
+              <a:ext uri="{FF2B5EF4-FFF2-40B4-BE49-F238E27FC236}">
+                <a16:creationId xmlns:a16="http://schemas.microsoft.com/office/drawing/2014/main" id="{C622CB07-5430-CC76-5423-39E8BEA20D90}"/>
+              </a:ext>
+            </a:extLst>
+          </p:cNvPr>
           <p:cNvSpPr>
             <a:spLocks noGrp="1" noRot="1" noChangeAspect="1"/>
           </p:cNvSpPr>
@@ -769,7 +585,13 @@
       </p:sp>
       <p:sp>
         <p:nvSpPr>
-          <p:cNvPr id="3" name="Notes Placeholder 2"/>
+          <p:cNvPr id="3" name="Notes Placeholder 2">
+            <a:extLst>
+              <a:ext uri="{FF2B5EF4-FFF2-40B4-BE49-F238E27FC236}">
+                <a16:creationId xmlns:a16="http://schemas.microsoft.com/office/drawing/2014/main" id="{4FD9DC72-E512-DB72-115E-ED947A03EB54}"/>
+              </a:ext>
+            </a:extLst>
+          </p:cNvPr>
           <p:cNvSpPr>
             <a:spLocks noGrp="1"/>
           </p:cNvSpPr>
@@ -786,13 +608,18 @@
               <a:rPr lang="en-US" dirty="0"/>
               <a:t>BACKUP (hidden). Fallback if the live demo fails. Say what it proves in one sentence.</a:t>
             </a:r>
-            <a:endParaRPr lang="en-US" dirty="0"/>
-          </a:p>
-        </p:txBody>
-      </p:sp>
-      <p:sp>
-        <p:nvSpPr>
-          <p:cNvPr id="4" name="Slide Number Placeholder 3"/>
+          </a:p>
+        </p:txBody>
+      </p:sp>
+      <p:sp>
+        <p:nvSpPr>
+          <p:cNvPr id="4" name="Slide Number Placeholder 3">
+            <a:extLst>
+              <a:ext uri="{FF2B5EF4-FFF2-40B4-BE49-F238E27FC236}">
+                <a16:creationId xmlns:a16="http://schemas.microsoft.com/office/drawing/2014/main" id="{09E1CCC5-7931-A340-BEE0-CBB75F7F8F59}"/>
+              </a:ext>
+            </a:extLst>
+          </p:cNvPr>
           <p:cNvSpPr>
             <a:spLocks noGrp="1"/>
           </p:cNvSpPr>
@@ -816,7 +643,7 @@
     </p:spTree>
     <p:extLst>
       <p:ext uri="{BB962C8B-B14F-4D97-AF65-F5344CB8AC3E}">
-        <p14:creationId xmlns:p14="http://schemas.microsoft.com/office/powerpoint/2010/main" val="1024086991"/>
+        <p14:creationId xmlns:p14="http://schemas.microsoft.com/office/powerpoint/2010/main" val="1504159359"/>
       </p:ext>
     </p:extLst>
   </p:cSld>
@@ -874,7 +701,6 @@
               <a:rPr lang="en-US" dirty="0"/>
               <a:t>BACKUP (hidden). Fallback if the live demo fails. Say what it proves in one sentence.</a:t>
             </a:r>
-            <a:endParaRPr lang="en-US" dirty="0"/>
           </a:p>
         </p:txBody>
       </p:sp>
@@ -960,9 +786,8 @@
           <a:p>
             <a:r>
               <a:rPr lang="en-US" dirty="0"/>
-              <a:t>BACKUP (hidden). For the 15-minute debrief only. Say: tools used, what you checked in AI output, what you assumed, what you would do next.</a:t>
-            </a:r>
-            <a:endParaRPr lang="en-US" dirty="0"/>
+              <a:t>BACKUP (hidden). Fallback if the live demo fails. Say what it proves in one sentence.</a:t>
+            </a:r>
           </a:p>
         </p:txBody>
       </p:sp>
@@ -984,6 +809,180 @@
             <a:fld id="{F7021451-1387-4CA6-816F-3879F97B5CBC}" type="slidenum">
               <a:rPr lang="en-US"/>
               <a:t>14</a:t>
+            </a:fld>
+            <a:endParaRPr lang="en-US"/>
+          </a:p>
+        </p:txBody>
+      </p:sp>
+    </p:spTree>
+    <p:extLst>
+      <p:ext uri="{BB962C8B-B14F-4D97-AF65-F5344CB8AC3E}">
+        <p14:creationId xmlns:p14="http://schemas.microsoft.com/office/powerpoint/2010/main" val="1024086991"/>
+      </p:ext>
+    </p:extLst>
+  </p:cSld>
+  <p:clrMapOvr>
+    <a:masterClrMapping/>
+  </p:clrMapOvr>
+</p:notes>
+</file>
+
+<file path=ppt/notesSlides/notesSlide15.xml><?xml version="1.0" encoding="utf-8"?>
+<p:notes xmlns:a="http://schemas.openxmlformats.org/drawingml/2006/main" xmlns:r="http://schemas.openxmlformats.org/officeDocument/2006/relationships" xmlns:p="http://schemas.openxmlformats.org/presentationml/2006/main">
+  <p:cSld>
+    <p:spTree>
+      <p:nvGrpSpPr>
+        <p:cNvPr id="1" name=""/>
+        <p:cNvGrpSpPr/>
+        <p:nvPr/>
+      </p:nvGrpSpPr>
+      <p:grpSpPr>
+        <a:xfrm>
+          <a:off x="0" y="0"/>
+          <a:ext cx="0" cy="0"/>
+          <a:chOff x="0" y="0"/>
+          <a:chExt cx="0" cy="0"/>
+        </a:xfrm>
+      </p:grpSpPr>
+      <p:sp>
+        <p:nvSpPr>
+          <p:cNvPr id="2" name="Slide Image Placeholder 1"/>
+          <p:cNvSpPr>
+            <a:spLocks noGrp="1" noRot="1" noChangeAspect="1"/>
+          </p:cNvSpPr>
+          <p:nvPr>
+            <p:ph type="sldImg"/>
+          </p:nvPr>
+        </p:nvSpPr>
+        <p:spPr/>
+      </p:sp>
+      <p:sp>
+        <p:nvSpPr>
+          <p:cNvPr id="3" name="Notes Placeholder 2"/>
+          <p:cNvSpPr>
+            <a:spLocks noGrp="1"/>
+          </p:cNvSpPr>
+          <p:nvPr>
+            <p:ph type="body" idx="1"/>
+          </p:nvPr>
+        </p:nvSpPr>
+        <p:spPr/>
+        <p:txBody>
+          <a:bodyPr/>
+          <a:lstStyle/>
+          <a:p>
+            <a:r>
+              <a:rPr lang="en-US" dirty="0"/>
+              <a:t>BACKUP (hidden). Fallback if the live demo fails. Say what it proves in one sentence.</a:t>
+            </a:r>
+          </a:p>
+        </p:txBody>
+      </p:sp>
+      <p:sp>
+        <p:nvSpPr>
+          <p:cNvPr id="4" name="Slide Number Placeholder 3"/>
+          <p:cNvSpPr>
+            <a:spLocks noGrp="1"/>
+          </p:cNvSpPr>
+          <p:nvPr>
+            <p:ph type="sldNum" sz="quarter" idx="10"/>
+          </p:nvPr>
+        </p:nvSpPr>
+        <p:spPr/>
+        <p:txBody>
+          <a:bodyPr/>
+          <a:lstStyle/>
+          <a:p>
+            <a:fld id="{F7021451-1387-4CA6-816F-3879F97B5CBC}" type="slidenum">
+              <a:rPr lang="en-US"/>
+              <a:t>15</a:t>
+            </a:fld>
+            <a:endParaRPr lang="en-US"/>
+          </a:p>
+        </p:txBody>
+      </p:sp>
+    </p:spTree>
+    <p:extLst>
+      <p:ext uri="{BB962C8B-B14F-4D97-AF65-F5344CB8AC3E}">
+        <p14:creationId xmlns:p14="http://schemas.microsoft.com/office/powerpoint/2010/main" val="1024086991"/>
+      </p:ext>
+    </p:extLst>
+  </p:cSld>
+  <p:clrMapOvr>
+    <a:masterClrMapping/>
+  </p:clrMapOvr>
+</p:notes>
+</file>
+
+<file path=ppt/notesSlides/notesSlide16.xml><?xml version="1.0" encoding="utf-8"?>
+<p:notes xmlns:a="http://schemas.openxmlformats.org/drawingml/2006/main" xmlns:r="http://schemas.openxmlformats.org/officeDocument/2006/relationships" xmlns:p="http://schemas.openxmlformats.org/presentationml/2006/main">
+  <p:cSld>
+    <p:spTree>
+      <p:nvGrpSpPr>
+        <p:cNvPr id="1" name=""/>
+        <p:cNvGrpSpPr/>
+        <p:nvPr/>
+      </p:nvGrpSpPr>
+      <p:grpSpPr>
+        <a:xfrm>
+          <a:off x="0" y="0"/>
+          <a:ext cx="0" cy="0"/>
+          <a:chOff x="0" y="0"/>
+          <a:chExt cx="0" cy="0"/>
+        </a:xfrm>
+      </p:grpSpPr>
+      <p:sp>
+        <p:nvSpPr>
+          <p:cNvPr id="2" name="Slide Image Placeholder 1"/>
+          <p:cNvSpPr>
+            <a:spLocks noGrp="1" noRot="1" noChangeAspect="1"/>
+          </p:cNvSpPr>
+          <p:nvPr>
+            <p:ph type="sldImg"/>
+          </p:nvPr>
+        </p:nvSpPr>
+        <p:spPr/>
+      </p:sp>
+      <p:sp>
+        <p:nvSpPr>
+          <p:cNvPr id="3" name="Notes Placeholder 2"/>
+          <p:cNvSpPr>
+            <a:spLocks noGrp="1"/>
+          </p:cNvSpPr>
+          <p:nvPr>
+            <p:ph type="body" idx="1"/>
+          </p:nvPr>
+        </p:nvSpPr>
+        <p:spPr/>
+        <p:txBody>
+          <a:bodyPr/>
+          <a:lstStyle/>
+          <a:p>
+            <a:r>
+              <a:rPr lang="en-US" dirty="0"/>
+              <a:t>BACKUP (hidden). For the 15-minute debrief only. Say: tools used, what you checked in AI output, what you assumed, what you would do next.</a:t>
+            </a:r>
+          </a:p>
+        </p:txBody>
+      </p:sp>
+      <p:sp>
+        <p:nvSpPr>
+          <p:cNvPr id="4" name="Slide Number Placeholder 3"/>
+          <p:cNvSpPr>
+            <a:spLocks noGrp="1"/>
+          </p:cNvSpPr>
+          <p:nvPr>
+            <p:ph type="sldNum" sz="quarter" idx="10"/>
+          </p:nvPr>
+        </p:nvSpPr>
+        <p:spPr/>
+        <p:txBody>
+          <a:bodyPr/>
+          <a:lstStyle/>
+          <a:p>
+            <a:fld id="{F7021451-1387-4CA6-816F-3879F97B5CBC}" type="slidenum">
+              <a:rPr lang="en-US"/>
+              <a:t>16</a:t>
             </a:fld>
             <a:endParaRPr lang="en-US"/>
           </a:p>
@@ -1056,7 +1055,6 @@
 AVOID: do not correct them, do not start solving, do not read the slide.
 IF THEY TALK LONG: good. Protect this slide; cut slide 3 depth instead.</a:t>
             </a:r>
-            <a:endParaRPr lang="en-US" dirty="0"/>
           </a:p>
         </p:txBody>
       </p:sp>
@@ -1149,7 +1147,6 @@
 AVOID: NO cost, pricing or TCO talk (they said it is out of scope). Value is outcomes: revenue protected, decisions sooner, risk reduced, time returned.
 BRIDGE: "Let me show you what that looks like on data shaped like yours." (go to the demo)</a:t>
             </a:r>
-            <a:endParaRPr lang="en-US" dirty="0"/>
           </a:p>
         </p:txBody>
       </p:sp>
@@ -1244,7 +1241,6 @@
 DEMO ORDER: 1 the target artifact answering the executive's question, 2 the technical leader's concern (freshness, governance, reliability), 3 the business leader's self-service question (Genie or the prompt library).
 IF IT BREAKS: "Let me show you the screenshot" (backup slides); keep talking.</a:t>
             </a:r>
-            <a:endParaRPr lang="en-US" dirty="0"/>
           </a:p>
         </p:txBody>
       </p:sp>
@@ -1337,7 +1333,6 @@
 LISTEN FOR: constraints on timing, approvals, a blocker you can pre-empt.
 AVOID: no price, no cost, no commercial terms; if asked: "Commercial terms follow the pilot; today I want to confirm the value."</a:t>
             </a:r>
-            <a:endParaRPr lang="en-US" dirty="0"/>
           </a:p>
         </p:txBody>
       </p:sp>
@@ -1430,7 +1425,6 @@
 CLOSE: read back the names and dates; thank each person by name; ask "what did I miss?".
 AVOID: do not open new topics in the last five minutes; no price talk.</a:t>
             </a:r>
-            <a:endParaRPr lang="en-US" dirty="0"/>
           </a:p>
         </p:txBody>
       </p:sp>
@@ -1518,7 +1512,6 @@
               <a:rPr lang="en-US" dirty="0"/>
               <a:t>BACKUP (hidden). Use when asked 'what did you assume?'. They said assumptions will not be challenged, but you must explain them and why they are reasonable. Say what you stood in for and what would change if it is different.</a:t>
             </a:r>
-            <a:endParaRPr lang="en-US" dirty="0"/>
           </a:p>
         </p:txBody>
       </p:sp>
@@ -1606,7 +1599,6 @@
               <a:rPr lang="en-US" dirty="0"/>
               <a:t>BACKUP (hidden). Use if the technical leader asks how the pieces fit. Mark built vs assumed.</a:t>
             </a:r>
-            <a:endParaRPr lang="en-US" dirty="0"/>
           </a:p>
         </p:txBody>
       </p:sp>
@@ -1694,7 +1686,6 @@
               <a:rPr lang="en-US" dirty="0"/>
               <a:t>BACKUP (hidden). Use if asked about tables or grain. State the grain of each table.</a:t>
             </a:r>
-            <a:endParaRPr lang="en-US" dirty="0"/>
           </a:p>
         </p:txBody>
       </p:sp>
@@ -1772,6 +1763,7 @@
         <a:solidFill>
           <a:srgbClr val="FFFFFF"/>
         </a:solidFill>
+        <a:effectLst/>
       </p:bgPr>
     </p:bg>
     <p:spTree>
@@ -1791,9 +1783,11 @@
       <p:sp>
         <p:nvSpPr>
           <p:cNvPr id="2" name="Text 0"/>
-          <p:cNvSpPr/>
+          <p:cNvSpPr>
+            <a:spLocks noGrp="1"/>
+          </p:cNvSpPr>
           <p:nvPr>
-            <p:ph idx="100" type="title" hasCustomPrompt="1"/>
+            <p:ph type="title" idx="100" hasCustomPrompt="1"/>
           </p:nvPr>
         </p:nvSpPr>
         <p:spPr>
@@ -1810,7 +1804,7 @@
         <p:txBody>
           <a:bodyPr wrap="square" rtlCol="0"/>
           <a:lstStyle>
-            <a:lvl1pPr algn="l" indent="0" marL="0">
+            <a:lvl1pPr marL="0" indent="0" algn="l">
               <a:buNone/>
               <a:defRPr lang="en-US" sz="3000" b="1" dirty="0">
                 <a:solidFill>
@@ -1823,7 +1817,7 @@
             </a:lvl1pPr>
           </a:lstStyle>
           <a:p>
-            <a:pPr algn="l" indent="0" marL="0">
+            <a:pPr marL="0" indent="0" algn="l">
               <a:buNone/>
             </a:pPr>
             <a:endParaRPr lang="en-US" sz="3000" dirty="0"/>
@@ -1850,7 +1844,7 @@
           </a:prstGeom>
           <a:extLst>
             <a:ext uri="{C572A759-6A51-4108-AA02-DFA0A04FC94B}">
-              <ma14:wrappingTextBoxFlag xmlns:ma14="http://schemas.microsoft.com/office/mac/drawingml/2011/main" val="0"/>
+              <ma14:wrappingTextBoxFlag xmlns:ma14="http://schemas.microsoft.com/office/mac/drawingml/2011/main" xmlns="" val="0"/>
             </a:ext>
           </a:extLst>
         </p:spPr>
@@ -1868,8 +1862,8 @@
           <a:p>
             <a:pPr algn="l"/>
             <a:fld id="{F7021451-1387-4CA6-816F-3879F97B5CBC}" type="slidenum">
-              <a:rPr b="0" lang="en-US"/>
-              <a:t>1002</a:t>
+              <a:rPr lang="en-US" b="0"/>
+              <a:t>‹#›</a:t>
             </a:fld>
             <a:endParaRPr lang="en-US"/>
           </a:p>
@@ -1886,6 +1880,11 @@
 <file path=ppt/slideMasters/slideMaster1.xml><?xml version="1.0" encoding="utf-8"?>
 <p:sldMaster xmlns:a="http://schemas.openxmlformats.org/drawingml/2006/main" xmlns:r="http://schemas.openxmlformats.org/officeDocument/2006/relationships" xmlns:p="http://schemas.openxmlformats.org/presentationml/2006/main">
   <p:cSld>
+    <p:bg>
+      <p:bgRef idx="1001">
+        <a:schemeClr val="bg1"/>
+      </p:bgRef>
+    </p:bg>
     <p:spTree>
       <p:nvGrpSpPr>
         <p:cNvPr id="1" name=""/>
@@ -1920,7 +1919,7 @@
           </a:prstGeom>
           <a:extLst>
             <a:ext uri="{C572A759-6A51-4108-AA02-DFA0A04FC94B}">
-              <ma14:wrappingTextBoxFlag xmlns:ma14="http://schemas.microsoft.com/office/mac/drawingml/2011/main" val="0"/>
+              <ma14:wrappingTextBoxFlag xmlns:ma14="http://schemas.microsoft.com/office/mac/drawingml/2011/main" xmlns="" val="0"/>
             </a:ext>
           </a:extLst>
         </p:spPr>
@@ -1938,8 +1937,8 @@
           <a:p>
             <a:pPr algn="l"/>
             <a:fld id="{F7021451-1387-4CA6-816F-3879F97B5CBC}" type="slidenum">
-              <a:rPr b="0" lang="en-US"/>
-              <a:t>null</a:t>
+              <a:rPr lang="en-US" b="0"/>
+              <a:t>‹#›</a:t>
             </a:fld>
             <a:endParaRPr lang="en-US"/>
           </a:p>
@@ -2226,9 +2225,11 @@
       <p:sp>
         <p:nvSpPr>
           <p:cNvPr id="2" name="Text 0"/>
-          <p:cNvSpPr/>
+          <p:cNvSpPr>
+            <a:spLocks noGrp="1"/>
+          </p:cNvSpPr>
           <p:nvPr>
-            <p:ph idx="100" type="title" hasCustomPrompt="1"/>
+            <p:ph type="title" idx="100" hasCustomPrompt="1"/>
           </p:nvPr>
         </p:nvSpPr>
         <p:spPr>
@@ -2246,7 +2247,7 @@
           <a:bodyPr wrap="square" lIns="0" tIns="0" rIns="0" bIns="0" rtlCol="0" anchor="ctr"/>
           <a:lstStyle/>
           <a:p>
-            <a:pPr algn="l" indent="0" marL="0">
+            <a:pPr marL="0" indent="0" algn="l">
               <a:buNone/>
             </a:pPr>
             <a:r>
@@ -2288,7 +2289,10 @@
         </p:spPr>
         <p:txBody>
           <a:bodyPr/>
-          <a:p/>
+          <a:lstStyle/>
+          <a:p>
+            <a:endParaRPr/>
+          </a:p>
         </p:txBody>
       </p:sp>
       <p:sp>
@@ -2312,7 +2316,7 @@
           <a:bodyPr wrap="square" lIns="0" tIns="0" rIns="0" bIns="0" rtlCol="0" anchor="ctr"/>
           <a:lstStyle/>
           <a:p>
-            <a:pPr indent="0" marL="0">
+            <a:pPr marL="0" indent="0">
               <a:buNone/>
             </a:pPr>
             <a:r>
@@ -2356,7 +2360,10 @@
         </p:spPr>
         <p:txBody>
           <a:bodyPr/>
-          <a:p/>
+          <a:lstStyle/>
+          <a:p>
+            <a:endParaRPr/>
+          </a:p>
         </p:txBody>
       </p:sp>
       <p:sp>
@@ -2380,7 +2387,7 @@
           <a:bodyPr wrap="square" lIns="0" tIns="0" rIns="0" bIns="0" rtlCol="0" anchor="ctr"/>
           <a:lstStyle/>
           <a:p>
-            <a:pPr indent="0" marL="0">
+            <a:pPr marL="0" indent="0">
               <a:buNone/>
             </a:pPr>
             <a:r>
@@ -2419,7 +2426,7 @@
           <a:bodyPr wrap="square" lIns="0" tIns="0" rIns="0" bIns="0" rtlCol="0" anchor="t"/>
           <a:lstStyle/>
           <a:p>
-            <a:pPr indent="0" marL="0">
+            <a:pPr marL="0" indent="0">
               <a:buNone/>
             </a:pPr>
             <a:r>
@@ -2458,7 +2465,7 @@
           <a:bodyPr wrap="square" lIns="0" tIns="0" rIns="0" bIns="0" rtlCol="0" anchor="t"/>
           <a:lstStyle/>
           <a:p>
-            <a:pPr indent="0" marL="0">
+            <a:pPr marL="0" indent="0">
               <a:buNone/>
             </a:pPr>
             <a:r>
@@ -2502,7 +2509,10 @@
         </p:spPr>
         <p:txBody>
           <a:bodyPr/>
-          <a:p/>
+          <a:lstStyle/>
+          <a:p>
+            <a:endParaRPr/>
+          </a:p>
         </p:txBody>
       </p:sp>
       <p:sp>
@@ -2526,7 +2536,7 @@
           <a:bodyPr wrap="square" lIns="0" tIns="0" rIns="0" bIns="0" rtlCol="0" anchor="ctr"/>
           <a:lstStyle/>
           <a:p>
-            <a:pPr indent="0" marL="0">
+            <a:pPr marL="0" indent="0">
               <a:buNone/>
             </a:pPr>
             <a:r>
@@ -2565,7 +2575,7 @@
           <a:bodyPr wrap="square" lIns="0" tIns="0" rIns="0" bIns="0" rtlCol="0" anchor="t"/>
           <a:lstStyle/>
           <a:p>
-            <a:pPr indent="0" marL="0">
+            <a:pPr marL="0" indent="0">
               <a:buNone/>
             </a:pPr>
             <a:r>
@@ -2604,7 +2614,7 @@
           <a:bodyPr wrap="square" lIns="0" tIns="0" rIns="0" bIns="0" rtlCol="0" anchor="t"/>
           <a:lstStyle/>
           <a:p>
-            <a:pPr indent="0" marL="0">
+            <a:pPr marL="0" indent="0">
               <a:buNone/>
             </a:pPr>
             <a:r>
@@ -2648,7 +2658,10 @@
         </p:spPr>
         <p:txBody>
           <a:bodyPr/>
-          <a:p/>
+          <a:lstStyle/>
+          <a:p>
+            <a:endParaRPr/>
+          </a:p>
         </p:txBody>
       </p:sp>
       <p:sp>
@@ -2672,7 +2685,7 @@
           <a:bodyPr wrap="square" lIns="0" tIns="0" rIns="0" bIns="0" rtlCol="0" anchor="ctr"/>
           <a:lstStyle/>
           <a:p>
-            <a:pPr indent="0" marL="0">
+            <a:pPr marL="0" indent="0">
               <a:buNone/>
             </a:pPr>
             <a:r>
@@ -2711,7 +2724,7 @@
           <a:bodyPr wrap="square" lIns="0" tIns="0" rIns="0" bIns="0" rtlCol="0" anchor="t"/>
           <a:lstStyle/>
           <a:p>
-            <a:pPr indent="0" marL="0">
+            <a:pPr marL="0" indent="0">
               <a:buNone/>
             </a:pPr>
             <a:r>
@@ -2750,7 +2763,7 @@
           <a:bodyPr wrap="square" lIns="0" tIns="0" rIns="0" bIns="0" rtlCol="0" anchor="t"/>
           <a:lstStyle/>
           <a:p>
-            <a:pPr indent="0" marL="0">
+            <a:pPr marL="0" indent="0">
               <a:buNone/>
             </a:pPr>
             <a:r>
@@ -2789,7 +2802,7 @@
           <a:bodyPr wrap="square" lIns="0" tIns="0" rIns="0" bIns="0" rtlCol="0" anchor="ctr"/>
           <a:lstStyle/>
           <a:p>
-            <a:pPr indent="0" marL="0">
+            <a:pPr marL="0" indent="0">
               <a:buNone/>
             </a:pPr>
             <a:r>
@@ -2827,7 +2840,7 @@
           </a:prstGeom>
           <a:extLst>
             <a:ext uri="{C572A759-6A51-4108-AA02-DFA0A04FC94B}">
-              <ma14:wrappingTextBoxFlag xmlns:ma14="http://schemas.microsoft.com/office/mac/drawingml/2011/main" val="0"/>
+              <ma14:wrappingTextBoxFlag xmlns:ma14="http://schemas.microsoft.com/office/mac/drawingml/2011/main" xmlns="" val="0"/>
             </a:ext>
           </a:extLst>
         </p:spPr>
@@ -2845,7 +2858,7 @@
           <a:p>
             <a:pPr algn="l"/>
             <a:fld id="{F7021451-1387-4CA6-816F-3879F97B5CBC}" type="slidenum">
-              <a:rPr b="0" lang="en-US"/>
+              <a:rPr lang="en-US" b="0"/>
               <a:t>1</a:t>
             </a:fld>
             <a:endParaRPr lang="en-US"/>
@@ -2880,15 +2893,17 @@
       <p:sp>
         <p:nvSpPr>
           <p:cNvPr id="2" name="Text 0"/>
-          <p:cNvSpPr/>
+          <p:cNvSpPr>
+            <a:spLocks noGrp="1"/>
+          </p:cNvSpPr>
           <p:nvPr>
-            <p:ph idx="100" type="title" hasCustomPrompt="1"/>
+            <p:ph type="title" idx="100" hasCustomPrompt="1"/>
           </p:nvPr>
         </p:nvSpPr>
         <p:spPr>
           <a:xfrm>
-            <a:off x="548640" y="320040"/>
-            <a:ext cx="8046720" cy="731520"/>
+            <a:off x="548640" y="0"/>
+            <a:ext cx="8046720" cy="426720"/>
           </a:xfrm>
           <a:prstGeom prst="rect">
             <a:avLst/>
@@ -2900,7 +2915,7 @@
           <a:bodyPr wrap="square" lIns="0" tIns="0" rIns="0" bIns="0" rtlCol="0" anchor="ctr"/>
           <a:lstStyle/>
           <a:p>
-            <a:pPr algn="l" indent="0" marL="0">
+            <a:pPr marL="0" indent="0" algn="l">
               <a:buNone/>
             </a:pPr>
             <a:r>
@@ -2944,7 +2959,10 @@
         </p:spPr>
         <p:txBody>
           <a:bodyPr/>
-          <a:p/>
+          <a:lstStyle/>
+          <a:p>
+            <a:endParaRPr/>
+          </a:p>
         </p:txBody>
       </p:sp>
       <p:sp>
@@ -2968,7 +2986,7 @@
           <a:bodyPr wrap="square" lIns="0" tIns="0" rIns="0" bIns="0" rtlCol="0" anchor="ctr"/>
           <a:lstStyle/>
           <a:p>
-            <a:pPr algn="ctr" indent="0" marL="0">
+            <a:pPr marL="0" indent="0" algn="ctr">
               <a:buNone/>
             </a:pPr>
             <a:r>
@@ -3006,7 +3024,7 @@
           </a:prstGeom>
           <a:extLst>
             <a:ext uri="{C572A759-6A51-4108-AA02-DFA0A04FC94B}">
-              <ma14:wrappingTextBoxFlag xmlns:ma14="http://schemas.microsoft.com/office/mac/drawingml/2011/main" val="0"/>
+              <ma14:wrappingTextBoxFlag xmlns:ma14="http://schemas.microsoft.com/office/mac/drawingml/2011/main" xmlns="" val="0"/>
             </a:ext>
           </a:extLst>
         </p:spPr>
@@ -3024,13 +3042,43 @@
           <a:p>
             <a:pPr algn="l"/>
             <a:fld id="{F7021451-1387-4CA6-816F-3879F97B5CBC}" type="slidenum">
-              <a:rPr b="0" lang="en-US"/>
+              <a:rPr lang="en-US" b="0"/>
               <a:t>10</a:t>
             </a:fld>
             <a:endParaRPr lang="en-US"/>
           </a:p>
         </p:txBody>
       </p:sp>
+      <p:pic>
+        <p:nvPicPr>
+          <p:cNvPr id="5" name="Picture 4">
+            <a:extLst>
+              <a:ext uri="{FF2B5EF4-FFF2-40B4-BE49-F238E27FC236}">
+                <a16:creationId xmlns:a16="http://schemas.microsoft.com/office/drawing/2014/main" id="{9387B8A3-36E4-FC9B-3BD2-B6FE8859A82D}"/>
+              </a:ext>
+            </a:extLst>
+          </p:cNvPr>
+          <p:cNvPicPr>
+            <a:picLocks noChangeAspect="1"/>
+          </p:cNvPicPr>
+          <p:nvPr/>
+        </p:nvPicPr>
+        <p:blipFill>
+          <a:blip r:embed="rId3"/>
+          <a:stretch>
+            <a:fillRect/>
+          </a:stretch>
+        </p:blipFill>
+        <p:spPr>
+          <a:xfrm>
+            <a:off x="116840" y="571500"/>
+            <a:ext cx="8956040" cy="4272316"/>
+          </a:xfrm>
+          <a:prstGeom prst="rect">
+            <a:avLst/>
+          </a:prstGeom>
+        </p:spPr>
+      </p:pic>
     </p:spTree>
   </p:cSld>
   <p:clrMapOvr>
@@ -3040,6 +3088,504 @@
 </file>
 
 <file path=ppt/slides/slide11.xml><?xml version="1.0" encoding="utf-8"?>
+<p:sld xmlns:a="http://schemas.openxmlformats.org/drawingml/2006/main" xmlns:r="http://schemas.openxmlformats.org/officeDocument/2006/relationships" xmlns:p="http://schemas.openxmlformats.org/presentationml/2006/main" show="0">
+  <p:cSld>
+    <p:spTree>
+      <p:nvGrpSpPr>
+        <p:cNvPr id="1" name="">
+          <a:extLst>
+            <a:ext uri="{FF2B5EF4-FFF2-40B4-BE49-F238E27FC236}">
+              <a16:creationId xmlns:a16="http://schemas.microsoft.com/office/drawing/2014/main" id="{B79A6DB0-7C4B-6113-46F5-0F1322C32434}"/>
+            </a:ext>
+          </a:extLst>
+        </p:cNvPr>
+        <p:cNvGrpSpPr/>
+        <p:nvPr/>
+      </p:nvGrpSpPr>
+      <p:grpSpPr>
+        <a:xfrm>
+          <a:off x="0" y="0"/>
+          <a:ext cx="0" cy="0"/>
+          <a:chOff x="0" y="0"/>
+          <a:chExt cx="0" cy="0"/>
+        </a:xfrm>
+      </p:grpSpPr>
+      <p:sp>
+        <p:nvSpPr>
+          <p:cNvPr id="2" name="Text 0">
+            <a:extLst>
+              <a:ext uri="{FF2B5EF4-FFF2-40B4-BE49-F238E27FC236}">
+                <a16:creationId xmlns:a16="http://schemas.microsoft.com/office/drawing/2014/main" id="{0F6F62FD-17F9-29B7-86F6-CD8CEF49CC2A}"/>
+              </a:ext>
+            </a:extLst>
+          </p:cNvPr>
+          <p:cNvSpPr>
+            <a:spLocks noGrp="1"/>
+          </p:cNvSpPr>
+          <p:nvPr>
+            <p:ph type="title" idx="100" hasCustomPrompt="1"/>
+          </p:nvPr>
+        </p:nvSpPr>
+        <p:spPr>
+          <a:xfrm>
+            <a:off x="548640" y="0"/>
+            <a:ext cx="8046720" cy="426720"/>
+          </a:xfrm>
+          <a:prstGeom prst="rect">
+            <a:avLst/>
+          </a:prstGeom>
+          <a:noFill/>
+          <a:ln/>
+        </p:spPr>
+        <p:txBody>
+          <a:bodyPr wrap="square" lIns="0" tIns="0" rIns="0" bIns="0" rtlCol="0" anchor="ctr"/>
+          <a:lstStyle/>
+          <a:p>
+            <a:pPr marL="0" indent="0" algn="l">
+              <a:buNone/>
+            </a:pPr>
+            <a:r>
+              <a:rPr lang="en-US" sz="3000" b="1" dirty="0">
+                <a:solidFill>
+                  <a:srgbClr val="1F2933"/>
+                </a:solidFill>
+                <a:latin typeface="Calibri" pitchFamily="34" charset="0"/>
+                <a:ea typeface="Calibri" pitchFamily="34" charset="-122"/>
+                <a:cs typeface="Calibri" pitchFamily="34" charset="-120"/>
+              </a:rPr>
+              <a:t>Backup: screenshot — Dashboard Merchandising and inventory page</a:t>
+            </a:r>
+            <a:endParaRPr lang="en-US" sz="3000" dirty="0"/>
+          </a:p>
+        </p:txBody>
+      </p:sp>
+      <p:sp>
+        <p:nvSpPr>
+          <p:cNvPr id="3" name="ph">
+            <a:extLst>
+              <a:ext uri="{FF2B5EF4-FFF2-40B4-BE49-F238E27FC236}">
+                <a16:creationId xmlns:a16="http://schemas.microsoft.com/office/drawing/2014/main" id="{9A0F2E1F-1F7D-6906-6DF2-59D2D9FABD09}"/>
+              </a:ext>
+            </a:extLst>
+          </p:cNvPr>
+          <p:cNvSpPr/>
+          <p:nvPr/>
+        </p:nvSpPr>
+        <p:spPr>
+          <a:xfrm>
+            <a:off x="548640" y="1188720"/>
+            <a:ext cx="8046720" cy="3383280"/>
+          </a:xfrm>
+          <a:prstGeom prst="rect">
+            <a:avLst/>
+          </a:prstGeom>
+          <a:solidFill>
+            <a:srgbClr val="FFFFFF"/>
+          </a:solidFill>
+          <a:ln w="12700">
+            <a:solidFill>
+              <a:srgbClr val="6B7280"/>
+            </a:solidFill>
+            <a:prstDash val="dash"/>
+          </a:ln>
+        </p:spPr>
+        <p:txBody>
+          <a:bodyPr/>
+          <a:lstStyle/>
+          <a:p>
+            <a:endParaRPr/>
+          </a:p>
+        </p:txBody>
+      </p:sp>
+      <p:sp>
+        <p:nvSpPr>
+          <p:cNvPr id="4" name="Text 2">
+            <a:extLst>
+              <a:ext uri="{FF2B5EF4-FFF2-40B4-BE49-F238E27FC236}">
+                <a16:creationId xmlns:a16="http://schemas.microsoft.com/office/drawing/2014/main" id="{15F51B03-123D-3AB8-ADC9-C89F7F852427}"/>
+              </a:ext>
+            </a:extLst>
+          </p:cNvPr>
+          <p:cNvSpPr txBox="1"/>
+          <p:nvPr/>
+        </p:nvSpPr>
+        <p:spPr>
+          <a:xfrm>
+            <a:off x="548640" y="1188720"/>
+            <a:ext cx="8046720" cy="3383280"/>
+          </a:xfrm>
+          <a:prstGeom prst="rect">
+            <a:avLst/>
+          </a:prstGeom>
+          <a:noFill/>
+          <a:ln/>
+        </p:spPr>
+        <p:txBody>
+          <a:bodyPr wrap="square" lIns="0" tIns="0" rIns="0" bIns="0" rtlCol="0" anchor="ctr"/>
+          <a:lstStyle/>
+          <a:p>
+            <a:pPr marL="0" indent="0" algn="ctr">
+              <a:buNone/>
+            </a:pPr>
+            <a:r>
+              <a:rPr lang="en-US" sz="1600" dirty="0">
+                <a:solidFill>
+                  <a:srgbClr val="6B7280"/>
+                </a:solidFill>
+                <a:latin typeface="Calibri" pitchFamily="34" charset="0"/>
+                <a:ea typeface="Calibri" pitchFamily="34" charset="-122"/>
+                <a:cs typeface="Calibri" pitchFamily="34" charset="-120"/>
+              </a:rPr>
+              <a:t>See demo/fallback/SCREENSHOTS_TO_TAKE.md — Merchandising and inventory page (stock-out exposure, worst-promotions table)</a:t>
+            </a:r>
+            <a:endParaRPr lang="en-US" sz="1600" dirty="0"/>
+          </a:p>
+        </p:txBody>
+      </p:sp>
+      <p:sp>
+        <p:nvSpPr>
+          <p:cNvPr id="25" name="Slide Number Placeholder 0">
+            <a:extLst>
+              <a:ext uri="{FF2B5EF4-FFF2-40B4-BE49-F238E27FC236}">
+                <a16:creationId xmlns:a16="http://schemas.microsoft.com/office/drawing/2014/main" id="{C63B8AA6-1D0B-05C9-13B3-8D36BFE6FDF4}"/>
+              </a:ext>
+            </a:extLst>
+          </p:cNvPr>
+          <p:cNvSpPr>
+            <a:spLocks noGrp="1"/>
+          </p:cNvSpPr>
+          <p:nvPr>
+            <p:ph type="sldNum" sz="quarter" idx="4294967295"/>
+          </p:nvPr>
+        </p:nvSpPr>
+        <p:spPr>
+          <a:xfrm>
+            <a:off x="8412480" y="4800600"/>
+            <a:ext cx="457200" cy="228600"/>
+          </a:xfrm>
+          <a:prstGeom prst="rect">
+            <a:avLst/>
+          </a:prstGeom>
+          <a:extLst>
+            <a:ext uri="{C572A759-6A51-4108-AA02-DFA0A04FC94B}">
+              <ma14:wrappingTextBoxFlag xmlns:ma14="http://schemas.microsoft.com/office/mac/drawingml/2011/main" xmlns="" val="0"/>
+            </a:ext>
+          </a:extLst>
+        </p:spPr>
+        <p:txBody>
+          <a:bodyPr/>
+          <a:lstStyle>
+            <a:lvl1pPr>
+              <a:defRPr sz="1000">
+                <a:solidFill>
+                  <a:srgbClr val="6B7280"/>
+                </a:solidFill>
+              </a:defRPr>
+            </a:lvl1pPr>
+          </a:lstStyle>
+          <a:p>
+            <a:pPr algn="l"/>
+            <a:fld id="{F7021451-1387-4CA6-816F-3879F97B5CBC}" type="slidenum">
+              <a:rPr lang="en-US" b="0"/>
+              <a:t>11</a:t>
+            </a:fld>
+            <a:endParaRPr lang="en-US"/>
+          </a:p>
+        </p:txBody>
+      </p:sp>
+      <p:pic>
+        <p:nvPicPr>
+          <p:cNvPr id="6" name="Picture 5">
+            <a:extLst>
+              <a:ext uri="{FF2B5EF4-FFF2-40B4-BE49-F238E27FC236}">
+                <a16:creationId xmlns:a16="http://schemas.microsoft.com/office/drawing/2014/main" id="{DDEBF112-D9C7-F492-301E-A9A61A99A3BF}"/>
+              </a:ext>
+            </a:extLst>
+          </p:cNvPr>
+          <p:cNvPicPr>
+            <a:picLocks noChangeAspect="1"/>
+          </p:cNvPicPr>
+          <p:nvPr/>
+        </p:nvPicPr>
+        <p:blipFill>
+          <a:blip r:embed="rId3"/>
+          <a:stretch>
+            <a:fillRect/>
+          </a:stretch>
+        </p:blipFill>
+        <p:spPr>
+          <a:xfrm>
+            <a:off x="157480" y="765810"/>
+            <a:ext cx="8712200" cy="4229100"/>
+          </a:xfrm>
+          <a:prstGeom prst="rect">
+            <a:avLst/>
+          </a:prstGeom>
+        </p:spPr>
+      </p:pic>
+    </p:spTree>
+    <p:extLst>
+      <p:ext uri="{BB962C8B-B14F-4D97-AF65-F5344CB8AC3E}">
+        <p14:creationId xmlns:p14="http://schemas.microsoft.com/office/powerpoint/2010/main" val="153349722"/>
+      </p:ext>
+    </p:extLst>
+  </p:cSld>
+  <p:clrMapOvr>
+    <a:masterClrMapping/>
+  </p:clrMapOvr>
+</p:sld>
+</file>
+
+<file path=ppt/slides/slide12.xml><?xml version="1.0" encoding="utf-8"?>
+<p:sld xmlns:a="http://schemas.openxmlformats.org/drawingml/2006/main" xmlns:r="http://schemas.openxmlformats.org/officeDocument/2006/relationships" xmlns:p="http://schemas.openxmlformats.org/presentationml/2006/main" show="0">
+  <p:cSld>
+    <p:spTree>
+      <p:nvGrpSpPr>
+        <p:cNvPr id="1" name="">
+          <a:extLst>
+            <a:ext uri="{FF2B5EF4-FFF2-40B4-BE49-F238E27FC236}">
+              <a16:creationId xmlns:a16="http://schemas.microsoft.com/office/drawing/2014/main" id="{91281ED9-8635-DC84-C5C5-2DE956819126}"/>
+            </a:ext>
+          </a:extLst>
+        </p:cNvPr>
+        <p:cNvGrpSpPr/>
+        <p:nvPr/>
+      </p:nvGrpSpPr>
+      <p:grpSpPr>
+        <a:xfrm>
+          <a:off x="0" y="0"/>
+          <a:ext cx="0" cy="0"/>
+          <a:chOff x="0" y="0"/>
+          <a:chExt cx="0" cy="0"/>
+        </a:xfrm>
+      </p:grpSpPr>
+      <p:sp>
+        <p:nvSpPr>
+          <p:cNvPr id="2" name="Text 0">
+            <a:extLst>
+              <a:ext uri="{FF2B5EF4-FFF2-40B4-BE49-F238E27FC236}">
+                <a16:creationId xmlns:a16="http://schemas.microsoft.com/office/drawing/2014/main" id="{D28F133B-1C44-7552-3201-130F947597D8}"/>
+              </a:ext>
+            </a:extLst>
+          </p:cNvPr>
+          <p:cNvSpPr>
+            <a:spLocks noGrp="1"/>
+          </p:cNvSpPr>
+          <p:nvPr>
+            <p:ph type="title" idx="100" hasCustomPrompt="1"/>
+          </p:nvPr>
+        </p:nvSpPr>
+        <p:spPr>
+          <a:xfrm>
+            <a:off x="548640" y="0"/>
+            <a:ext cx="8046720" cy="426720"/>
+          </a:xfrm>
+          <a:prstGeom prst="rect">
+            <a:avLst/>
+          </a:prstGeom>
+          <a:noFill/>
+          <a:ln/>
+        </p:spPr>
+        <p:txBody>
+          <a:bodyPr wrap="square" lIns="0" tIns="0" rIns="0" bIns="0" rtlCol="0" anchor="ctr"/>
+          <a:lstStyle/>
+          <a:p>
+            <a:pPr marL="0" indent="0" algn="l">
+              <a:buNone/>
+            </a:pPr>
+            <a:r>
+              <a:rPr lang="en-US" sz="3000" b="1" dirty="0">
+                <a:solidFill>
+                  <a:srgbClr val="1F2933"/>
+                </a:solidFill>
+                <a:latin typeface="Calibri" pitchFamily="34" charset="0"/>
+                <a:ea typeface="Calibri" pitchFamily="34" charset="-122"/>
+                <a:cs typeface="Calibri" pitchFamily="34" charset="-120"/>
+              </a:rPr>
+              <a:t>Backup: screenshot — Dashboard Store operations and customer page (Trust tile)</a:t>
+            </a:r>
+            <a:endParaRPr lang="en-US" sz="3000" dirty="0"/>
+          </a:p>
+        </p:txBody>
+      </p:sp>
+      <p:sp>
+        <p:nvSpPr>
+          <p:cNvPr id="3" name="ph">
+            <a:extLst>
+              <a:ext uri="{FF2B5EF4-FFF2-40B4-BE49-F238E27FC236}">
+                <a16:creationId xmlns:a16="http://schemas.microsoft.com/office/drawing/2014/main" id="{FBC154D7-B109-7584-482C-77D58B8B89C0}"/>
+              </a:ext>
+            </a:extLst>
+          </p:cNvPr>
+          <p:cNvSpPr/>
+          <p:nvPr/>
+        </p:nvSpPr>
+        <p:spPr>
+          <a:xfrm>
+            <a:off x="548640" y="1188720"/>
+            <a:ext cx="8046720" cy="3383280"/>
+          </a:xfrm>
+          <a:prstGeom prst="rect">
+            <a:avLst/>
+          </a:prstGeom>
+          <a:solidFill>
+            <a:srgbClr val="FFFFFF"/>
+          </a:solidFill>
+          <a:ln w="12700">
+            <a:solidFill>
+              <a:srgbClr val="6B7280"/>
+            </a:solidFill>
+            <a:prstDash val="dash"/>
+          </a:ln>
+        </p:spPr>
+        <p:txBody>
+          <a:bodyPr/>
+          <a:lstStyle/>
+          <a:p>
+            <a:endParaRPr/>
+          </a:p>
+        </p:txBody>
+      </p:sp>
+      <p:sp>
+        <p:nvSpPr>
+          <p:cNvPr id="4" name="Text 2">
+            <a:extLst>
+              <a:ext uri="{FF2B5EF4-FFF2-40B4-BE49-F238E27FC236}">
+                <a16:creationId xmlns:a16="http://schemas.microsoft.com/office/drawing/2014/main" id="{EBEF49E8-B061-8829-2B23-6A5FFA2B01C6}"/>
+              </a:ext>
+            </a:extLst>
+          </p:cNvPr>
+          <p:cNvSpPr txBox="1"/>
+          <p:nvPr/>
+        </p:nvSpPr>
+        <p:spPr>
+          <a:xfrm>
+            <a:off x="548640" y="1188720"/>
+            <a:ext cx="8046720" cy="3383280"/>
+          </a:xfrm>
+          <a:prstGeom prst="rect">
+            <a:avLst/>
+          </a:prstGeom>
+          <a:noFill/>
+          <a:ln/>
+        </p:spPr>
+        <p:txBody>
+          <a:bodyPr wrap="square" lIns="0" tIns="0" rIns="0" bIns="0" rtlCol="0" anchor="ctr"/>
+          <a:lstStyle/>
+          <a:p>
+            <a:pPr marL="0" indent="0" algn="ctr">
+              <a:buNone/>
+            </a:pPr>
+            <a:r>
+              <a:rPr lang="en-US" sz="1600" dirty="0">
+                <a:solidFill>
+                  <a:srgbClr val="6B7280"/>
+                </a:solidFill>
+                <a:latin typeface="Calibri" pitchFamily="34" charset="0"/>
+                <a:ea typeface="Calibri" pitchFamily="34" charset="-122"/>
+                <a:cs typeface="Calibri" pitchFamily="34" charset="-120"/>
+              </a:rPr>
+              <a:t>See demo/fallback/SCREENSHOTS_TO_TAKE.md — Store operations and customer page (loyalty retention, basket affinity, Trust tile)</a:t>
+            </a:r>
+            <a:endParaRPr lang="en-US" sz="1600" dirty="0"/>
+          </a:p>
+        </p:txBody>
+      </p:sp>
+      <p:sp>
+        <p:nvSpPr>
+          <p:cNvPr id="25" name="Slide Number Placeholder 0">
+            <a:extLst>
+              <a:ext uri="{FF2B5EF4-FFF2-40B4-BE49-F238E27FC236}">
+                <a16:creationId xmlns:a16="http://schemas.microsoft.com/office/drawing/2014/main" id="{7AB5E976-8128-86B3-2721-57F5E9BA83ED}"/>
+              </a:ext>
+            </a:extLst>
+          </p:cNvPr>
+          <p:cNvSpPr>
+            <a:spLocks noGrp="1"/>
+          </p:cNvSpPr>
+          <p:nvPr>
+            <p:ph type="sldNum" sz="quarter" idx="4294967295"/>
+          </p:nvPr>
+        </p:nvSpPr>
+        <p:spPr>
+          <a:xfrm>
+            <a:off x="8412480" y="4800600"/>
+            <a:ext cx="457200" cy="228600"/>
+          </a:xfrm>
+          <a:prstGeom prst="rect">
+            <a:avLst/>
+          </a:prstGeom>
+          <a:extLst>
+            <a:ext uri="{C572A759-6A51-4108-AA02-DFA0A04FC94B}">
+              <ma14:wrappingTextBoxFlag xmlns:ma14="http://schemas.microsoft.com/office/mac/drawingml/2011/main" xmlns="" val="0"/>
+            </a:ext>
+          </a:extLst>
+        </p:spPr>
+        <p:txBody>
+          <a:bodyPr/>
+          <a:lstStyle>
+            <a:lvl1pPr>
+              <a:defRPr sz="1000">
+                <a:solidFill>
+                  <a:srgbClr val="6B7280"/>
+                </a:solidFill>
+              </a:defRPr>
+            </a:lvl1pPr>
+          </a:lstStyle>
+          <a:p>
+            <a:pPr algn="l"/>
+            <a:fld id="{F7021451-1387-4CA6-816F-3879F97B5CBC}" type="slidenum">
+              <a:rPr lang="en-US" b="0"/>
+              <a:t>12</a:t>
+            </a:fld>
+            <a:endParaRPr lang="en-US"/>
+          </a:p>
+        </p:txBody>
+      </p:sp>
+      <p:pic>
+        <p:nvPicPr>
+          <p:cNvPr id="5" name="Picture 4">
+            <a:extLst>
+              <a:ext uri="{FF2B5EF4-FFF2-40B4-BE49-F238E27FC236}">
+                <a16:creationId xmlns:a16="http://schemas.microsoft.com/office/drawing/2014/main" id="{E5EE28DE-F3A6-2BE7-CD68-D3C3AFBFCC1A}"/>
+              </a:ext>
+            </a:extLst>
+          </p:cNvPr>
+          <p:cNvPicPr>
+            <a:picLocks noChangeAspect="1"/>
+          </p:cNvPicPr>
+          <p:nvPr/>
+        </p:nvPicPr>
+        <p:blipFill>
+          <a:blip r:embed="rId3"/>
+          <a:stretch>
+            <a:fillRect/>
+          </a:stretch>
+        </p:blipFill>
+        <p:spPr>
+          <a:xfrm>
+            <a:off x="228599" y="571500"/>
+            <a:ext cx="8728529" cy="4102100"/>
+          </a:xfrm>
+          <a:prstGeom prst="rect">
+            <a:avLst/>
+          </a:prstGeom>
+        </p:spPr>
+      </p:pic>
+    </p:spTree>
+    <p:extLst>
+      <p:ext uri="{BB962C8B-B14F-4D97-AF65-F5344CB8AC3E}">
+        <p14:creationId xmlns:p14="http://schemas.microsoft.com/office/powerpoint/2010/main" val="4081044663"/>
+      </p:ext>
+    </p:extLst>
+  </p:cSld>
+  <p:clrMapOvr>
+    <a:masterClrMapping/>
+  </p:clrMapOvr>
+</p:sld>
+</file>
+
+<file path=ppt/slides/slide13.xml><?xml version="1.0" encoding="utf-8"?>
 <p:sld xmlns:a="http://schemas.openxmlformats.org/drawingml/2006/main" xmlns:r="http://schemas.openxmlformats.org/officeDocument/2006/relationships" xmlns:p="http://schemas.openxmlformats.org/presentationml/2006/main" show="0">
   <p:cSld name="Slide 11">
     <p:spTree>
@@ -3059,15 +3605,17 @@
       <p:sp>
         <p:nvSpPr>
           <p:cNvPr id="2" name="Text 0"/>
-          <p:cNvSpPr/>
+          <p:cNvSpPr>
+            <a:spLocks noGrp="1"/>
+          </p:cNvSpPr>
           <p:nvPr>
-            <p:ph idx="100" type="title" hasCustomPrompt="1"/>
+            <p:ph type="title" idx="100" hasCustomPrompt="1"/>
           </p:nvPr>
         </p:nvSpPr>
         <p:spPr>
           <a:xfrm>
-            <a:off x="548640" y="320040"/>
-            <a:ext cx="8046720" cy="731520"/>
+            <a:off x="548640" y="0"/>
+            <a:ext cx="8046720" cy="487680"/>
           </a:xfrm>
           <a:prstGeom prst="rect">
             <a:avLst/>
@@ -3079,7 +3627,7 @@
           <a:bodyPr wrap="square" lIns="0" tIns="0" rIns="0" bIns="0" rtlCol="0" anchor="ctr"/>
           <a:lstStyle/>
           <a:p>
-            <a:pPr algn="l" indent="0" marL="0">
+            <a:pPr marL="0" indent="0" algn="l">
               <a:buNone/>
             </a:pPr>
             <a:r>
@@ -3123,7 +3671,10 @@
         </p:spPr>
         <p:txBody>
           <a:bodyPr/>
-          <a:p/>
+          <a:lstStyle/>
+          <a:p>
+            <a:endParaRPr/>
+          </a:p>
         </p:txBody>
       </p:sp>
       <p:sp>
@@ -3147,7 +3698,7 @@
           <a:bodyPr wrap="square" lIns="0" tIns="0" rIns="0" bIns="0" rtlCol="0" anchor="ctr"/>
           <a:lstStyle/>
           <a:p>
-            <a:pPr algn="ctr" indent="0" marL="0">
+            <a:pPr marL="0" indent="0" algn="ctr">
               <a:buNone/>
             </a:pPr>
             <a:r>
@@ -3185,7 +3736,7 @@
           </a:prstGeom>
           <a:extLst>
             <a:ext uri="{C572A759-6A51-4108-AA02-DFA0A04FC94B}">
-              <ma14:wrappingTextBoxFlag xmlns:ma14="http://schemas.microsoft.com/office/mac/drawingml/2011/main" val="0"/>
+              <ma14:wrappingTextBoxFlag xmlns:ma14="http://schemas.microsoft.com/office/mac/drawingml/2011/main" xmlns="" val="0"/>
             </a:ext>
           </a:extLst>
         </p:spPr>
@@ -3203,13 +3754,43 @@
           <a:p>
             <a:pPr algn="l"/>
             <a:fld id="{F7021451-1387-4CA6-816F-3879F97B5CBC}" type="slidenum">
-              <a:rPr b="0" lang="en-US"/>
-              <a:t>11</a:t>
+              <a:rPr lang="en-US" b="0"/>
+              <a:t>13</a:t>
             </a:fld>
             <a:endParaRPr lang="en-US"/>
           </a:p>
         </p:txBody>
       </p:sp>
+      <p:pic>
+        <p:nvPicPr>
+          <p:cNvPr id="5" name="Picture 4">
+            <a:extLst>
+              <a:ext uri="{FF2B5EF4-FFF2-40B4-BE49-F238E27FC236}">
+                <a16:creationId xmlns:a16="http://schemas.microsoft.com/office/drawing/2014/main" id="{692F850A-871F-A0B5-77A4-17E372A3B89C}"/>
+              </a:ext>
+            </a:extLst>
+          </p:cNvPr>
+          <p:cNvPicPr>
+            <a:picLocks noChangeAspect="1"/>
+          </p:cNvPicPr>
+          <p:nvPr/>
+        </p:nvPicPr>
+        <p:blipFill>
+          <a:blip r:embed="rId3"/>
+          <a:stretch>
+            <a:fillRect/>
+          </a:stretch>
+        </p:blipFill>
+        <p:spPr>
+          <a:xfrm>
+            <a:off x="106680" y="487680"/>
+            <a:ext cx="8852838" cy="4312920"/>
+          </a:xfrm>
+          <a:prstGeom prst="rect">
+            <a:avLst/>
+          </a:prstGeom>
+        </p:spPr>
+      </p:pic>
     </p:spTree>
   </p:cSld>
   <p:clrMapOvr>
@@ -3218,7 +3799,7 @@
 </p:sld>
 </file>
 
-<file path=ppt/slides/slide12.xml><?xml version="1.0" encoding="utf-8"?>
+<file path=ppt/slides/slide14.xml><?xml version="1.0" encoding="utf-8"?>
 <p:sld xmlns:a="http://schemas.openxmlformats.org/drawingml/2006/main" xmlns:r="http://schemas.openxmlformats.org/officeDocument/2006/relationships" xmlns:p="http://schemas.openxmlformats.org/presentationml/2006/main" show="0">
   <p:cSld name="Slide 12">
     <p:spTree>
@@ -3238,15 +3819,17 @@
       <p:sp>
         <p:nvSpPr>
           <p:cNvPr id="2" name="Text 0"/>
-          <p:cNvSpPr/>
+          <p:cNvSpPr>
+            <a:spLocks noGrp="1"/>
+          </p:cNvSpPr>
           <p:nvPr>
-            <p:ph idx="100" type="title" hasCustomPrompt="1"/>
+            <p:ph type="title" idx="100" hasCustomPrompt="1"/>
           </p:nvPr>
         </p:nvSpPr>
         <p:spPr>
           <a:xfrm>
-            <a:off x="548640" y="320040"/>
-            <a:ext cx="8046720" cy="731520"/>
+            <a:off x="548640" y="114300"/>
+            <a:ext cx="8046720" cy="353060"/>
           </a:xfrm>
           <a:prstGeom prst="rect">
             <a:avLst/>
@@ -3258,7 +3841,7 @@
           <a:bodyPr wrap="square" lIns="0" tIns="0" rIns="0" bIns="0" rtlCol="0" anchor="ctr"/>
           <a:lstStyle/>
           <a:p>
-            <a:pPr algn="l" indent="0" marL="0">
+            <a:pPr marL="0" indent="0" algn="l">
               <a:buNone/>
             </a:pPr>
             <a:r>
@@ -3302,7 +3885,10 @@
         </p:spPr>
         <p:txBody>
           <a:bodyPr/>
-          <a:p/>
+          <a:lstStyle/>
+          <a:p>
+            <a:endParaRPr/>
+          </a:p>
         </p:txBody>
       </p:sp>
       <p:sp>
@@ -3326,7 +3912,7 @@
           <a:bodyPr wrap="square" lIns="0" tIns="0" rIns="0" bIns="0" rtlCol="0" anchor="ctr"/>
           <a:lstStyle/>
           <a:p>
-            <a:pPr algn="ctr" indent="0" marL="0">
+            <a:pPr marL="0" indent="0" algn="ctr">
               <a:buNone/>
             </a:pPr>
             <a:r>
@@ -3364,7 +3950,7 @@
           </a:prstGeom>
           <a:extLst>
             <a:ext uri="{C572A759-6A51-4108-AA02-DFA0A04FC94B}">
-              <ma14:wrappingTextBoxFlag xmlns:ma14="http://schemas.microsoft.com/office/mac/drawingml/2011/main" val="0"/>
+              <ma14:wrappingTextBoxFlag xmlns:ma14="http://schemas.microsoft.com/office/mac/drawingml/2011/main" xmlns="" val="0"/>
             </a:ext>
           </a:extLst>
         </p:spPr>
@@ -3382,13 +3968,43 @@
           <a:p>
             <a:pPr algn="l"/>
             <a:fld id="{F7021451-1387-4CA6-816F-3879F97B5CBC}" type="slidenum">
-              <a:rPr b="0" lang="en-US"/>
-              <a:t>12</a:t>
+              <a:rPr lang="en-US" b="0"/>
+              <a:t>14</a:t>
             </a:fld>
             <a:endParaRPr lang="en-US"/>
           </a:p>
         </p:txBody>
       </p:sp>
+      <p:pic>
+        <p:nvPicPr>
+          <p:cNvPr id="5" name="Picture 4">
+            <a:extLst>
+              <a:ext uri="{FF2B5EF4-FFF2-40B4-BE49-F238E27FC236}">
+                <a16:creationId xmlns:a16="http://schemas.microsoft.com/office/drawing/2014/main" id="{92176AA7-20DF-1BE0-D700-97D0F7F52140}"/>
+              </a:ext>
+            </a:extLst>
+          </p:cNvPr>
+          <p:cNvPicPr>
+            <a:picLocks noChangeAspect="1"/>
+          </p:cNvPicPr>
+          <p:nvPr/>
+        </p:nvPicPr>
+        <p:blipFill>
+          <a:blip r:embed="rId3"/>
+          <a:stretch>
+            <a:fillRect/>
+          </a:stretch>
+        </p:blipFill>
+        <p:spPr>
+          <a:xfrm>
+            <a:off x="269240" y="571500"/>
+            <a:ext cx="8600440" cy="4141288"/>
+          </a:xfrm>
+          <a:prstGeom prst="rect">
+            <a:avLst/>
+          </a:prstGeom>
+        </p:spPr>
+      </p:pic>
     </p:spTree>
   </p:cSld>
   <p:clrMapOvr>
@@ -3397,7 +4013,7 @@
 </p:sld>
 </file>
 
-<file path=ppt/slides/slide13.xml><?xml version="1.0" encoding="utf-8"?>
+<file path=ppt/slides/slide15.xml><?xml version="1.0" encoding="utf-8"?>
 <p:sld xmlns:a="http://schemas.openxmlformats.org/drawingml/2006/main" xmlns:r="http://schemas.openxmlformats.org/officeDocument/2006/relationships" xmlns:p="http://schemas.openxmlformats.org/presentationml/2006/main" show="0">
   <p:cSld name="Slide 13">
     <p:spTree>
@@ -3417,15 +4033,17 @@
       <p:sp>
         <p:nvSpPr>
           <p:cNvPr id="2" name="Text 0"/>
-          <p:cNvSpPr/>
+          <p:cNvSpPr>
+            <a:spLocks noGrp="1"/>
+          </p:cNvSpPr>
           <p:nvPr>
-            <p:ph idx="100" type="title" hasCustomPrompt="1"/>
+            <p:ph type="title" idx="100" hasCustomPrompt="1"/>
           </p:nvPr>
         </p:nvSpPr>
         <p:spPr>
           <a:xfrm>
-            <a:off x="548640" y="320040"/>
-            <a:ext cx="8046720" cy="731520"/>
+            <a:off x="548640" y="114300"/>
+            <a:ext cx="8046720" cy="457200"/>
           </a:xfrm>
           <a:prstGeom prst="rect">
             <a:avLst/>
@@ -3437,7 +4055,7 @@
           <a:bodyPr wrap="square" lIns="0" tIns="0" rIns="0" bIns="0" rtlCol="0" anchor="ctr"/>
           <a:lstStyle/>
           <a:p>
-            <a:pPr algn="l" indent="0" marL="0">
+            <a:pPr marL="0" indent="0" algn="l">
               <a:buNone/>
             </a:pPr>
             <a:r>
@@ -3481,7 +4099,10 @@
         </p:spPr>
         <p:txBody>
           <a:bodyPr/>
-          <a:p/>
+          <a:lstStyle/>
+          <a:p>
+            <a:endParaRPr/>
+          </a:p>
         </p:txBody>
       </p:sp>
       <p:sp>
@@ -3505,7 +4126,7 @@
           <a:bodyPr wrap="square" lIns="0" tIns="0" rIns="0" bIns="0" rtlCol="0" anchor="ctr"/>
           <a:lstStyle/>
           <a:p>
-            <a:pPr algn="ctr" indent="0" marL="0">
+            <a:pPr marL="0" indent="0" algn="ctr">
               <a:buNone/>
             </a:pPr>
             <a:r>
@@ -3543,7 +4164,7 @@
           </a:prstGeom>
           <a:extLst>
             <a:ext uri="{C572A759-6A51-4108-AA02-DFA0A04FC94B}">
-              <ma14:wrappingTextBoxFlag xmlns:ma14="http://schemas.microsoft.com/office/mac/drawingml/2011/main" val="0"/>
+              <ma14:wrappingTextBoxFlag xmlns:ma14="http://schemas.microsoft.com/office/mac/drawingml/2011/main" xmlns="" val="0"/>
             </a:ext>
           </a:extLst>
         </p:spPr>
@@ -3561,13 +4182,43 @@
           <a:p>
             <a:pPr algn="l"/>
             <a:fld id="{F7021451-1387-4CA6-816F-3879F97B5CBC}" type="slidenum">
-              <a:rPr b="0" lang="en-US"/>
-              <a:t>13</a:t>
+              <a:rPr lang="en-US" b="0"/>
+              <a:t>15</a:t>
             </a:fld>
             <a:endParaRPr lang="en-US"/>
           </a:p>
         </p:txBody>
       </p:sp>
+      <p:pic>
+        <p:nvPicPr>
+          <p:cNvPr id="5" name="Picture 4">
+            <a:extLst>
+              <a:ext uri="{FF2B5EF4-FFF2-40B4-BE49-F238E27FC236}">
+                <a16:creationId xmlns:a16="http://schemas.microsoft.com/office/drawing/2014/main" id="{EEFAD5F3-7BCB-6345-EF4F-714F803A0197}"/>
+              </a:ext>
+            </a:extLst>
+          </p:cNvPr>
+          <p:cNvPicPr>
+            <a:picLocks noChangeAspect="1"/>
+          </p:cNvPicPr>
+          <p:nvPr/>
+        </p:nvPicPr>
+        <p:blipFill>
+          <a:blip r:embed="rId3"/>
+          <a:stretch>
+            <a:fillRect/>
+          </a:stretch>
+        </p:blipFill>
+        <p:spPr>
+          <a:xfrm>
+            <a:off x="127000" y="571500"/>
+            <a:ext cx="8915400" cy="4292948"/>
+          </a:xfrm>
+          <a:prstGeom prst="rect">
+            <a:avLst/>
+          </a:prstGeom>
+        </p:spPr>
+      </p:pic>
     </p:spTree>
   </p:cSld>
   <p:clrMapOvr>
@@ -3576,7 +4227,7 @@
 </p:sld>
 </file>
 
-<file path=ppt/slides/slide14.xml><?xml version="1.0" encoding="utf-8"?>
+<file path=ppt/slides/slide16.xml><?xml version="1.0" encoding="utf-8"?>
 <p:sld xmlns:a="http://schemas.openxmlformats.org/drawingml/2006/main" xmlns:r="http://schemas.openxmlformats.org/officeDocument/2006/relationships" xmlns:p="http://schemas.openxmlformats.org/presentationml/2006/main" show="0">
   <p:cSld name="Slide 14">
     <p:spTree>
@@ -3596,15 +4247,17 @@
       <p:sp>
         <p:nvSpPr>
           <p:cNvPr id="2" name="Text 0"/>
-          <p:cNvSpPr/>
+          <p:cNvSpPr>
+            <a:spLocks noGrp="1"/>
+          </p:cNvSpPr>
           <p:nvPr>
-            <p:ph idx="100" type="title" hasCustomPrompt="1"/>
+            <p:ph type="title" idx="100" hasCustomPrompt="1"/>
           </p:nvPr>
         </p:nvSpPr>
         <p:spPr>
           <a:xfrm>
-            <a:off x="548640" y="320040"/>
-            <a:ext cx="8046720" cy="731520"/>
+            <a:off x="548640" y="114300"/>
+            <a:ext cx="8046720" cy="457200"/>
           </a:xfrm>
           <a:prstGeom prst="rect">
             <a:avLst/>
@@ -3616,7 +4269,7 @@
           <a:bodyPr wrap="square" lIns="0" tIns="0" rIns="0" bIns="0" rtlCol="0" anchor="ctr"/>
           <a:lstStyle/>
           <a:p>
-            <a:pPr algn="l" indent="0" marL="0">
+            <a:pPr marL="0" indent="0" algn="l">
               <a:buNone/>
             </a:pPr>
             <a:r>
@@ -3660,7 +4313,10 @@
         </p:spPr>
         <p:txBody>
           <a:bodyPr/>
-          <a:p/>
+          <a:lstStyle/>
+          <a:p>
+            <a:endParaRPr/>
+          </a:p>
         </p:txBody>
       </p:sp>
       <p:sp>
@@ -3684,7 +4340,7 @@
           <a:bodyPr wrap="square" lIns="0" tIns="0" rIns="0" bIns="0" rtlCol="0" anchor="ctr"/>
           <a:lstStyle/>
           <a:p>
-            <a:pPr algn="ctr" indent="0" marL="0">
+            <a:pPr marL="0" indent="0" algn="ctr">
               <a:buNone/>
             </a:pPr>
             <a:r>
@@ -3722,7 +4378,7 @@
           </a:prstGeom>
           <a:extLst>
             <a:ext uri="{C572A759-6A51-4108-AA02-DFA0A04FC94B}">
-              <ma14:wrappingTextBoxFlag xmlns:ma14="http://schemas.microsoft.com/office/mac/drawingml/2011/main" val="0"/>
+              <ma14:wrappingTextBoxFlag xmlns:ma14="http://schemas.microsoft.com/office/mac/drawingml/2011/main" xmlns="" val="0"/>
             </a:ext>
           </a:extLst>
         </p:spPr>
@@ -3740,8 +4396,8 @@
           <a:p>
             <a:pPr algn="l"/>
             <a:fld id="{F7021451-1387-4CA6-816F-3879F97B5CBC}" type="slidenum">
-              <a:rPr b="0" lang="en-US"/>
-              <a:t>14</a:t>
+              <a:rPr lang="en-US" b="0"/>
+              <a:t>16</a:t>
             </a:fld>
             <a:endParaRPr lang="en-US"/>
           </a:p>
@@ -3749,7 +4405,13 @@
       </p:sp>
       <p:pic>
         <p:nvPicPr>
-          <p:cNvPr id="26" name="Picture 25" descr="toolchain.jpg"/>
+          <p:cNvPr id="6" name="Picture 5">
+            <a:extLst>
+              <a:ext uri="{FF2B5EF4-FFF2-40B4-BE49-F238E27FC236}">
+                <a16:creationId xmlns:a16="http://schemas.microsoft.com/office/drawing/2014/main" id="{A215CF13-84D4-9005-ED39-0DFDF70A185D}"/>
+              </a:ext>
+            </a:extLst>
+          </p:cNvPr>
           <p:cNvPicPr>
             <a:picLocks noChangeAspect="1"/>
           </p:cNvPicPr>
@@ -3763,8 +4425,8 @@
         </p:blipFill>
         <p:spPr>
           <a:xfrm>
-            <a:off x="548640" y="1188720"/>
-            <a:ext cx="8046720" cy="2973238"/>
+            <a:off x="548640" y="551180"/>
+            <a:ext cx="8158480" cy="4380974"/>
           </a:xfrm>
           <a:prstGeom prst="rect">
             <a:avLst/>
@@ -3799,9 +4461,11 @@
       <p:sp>
         <p:nvSpPr>
           <p:cNvPr id="2" name="Text 0"/>
-          <p:cNvSpPr/>
+          <p:cNvSpPr>
+            <a:spLocks noGrp="1"/>
+          </p:cNvSpPr>
           <p:nvPr>
-            <p:ph idx="100" type="title" hasCustomPrompt="1"/>
+            <p:ph type="title" idx="100" hasCustomPrompt="1"/>
           </p:nvPr>
         </p:nvSpPr>
         <p:spPr>
@@ -3819,7 +4483,7 @@
           <a:bodyPr wrap="square" lIns="0" tIns="0" rIns="0" bIns="0" rtlCol="0" anchor="ctr"/>
           <a:lstStyle/>
           <a:p>
-            <a:pPr algn="l" indent="0" marL="0">
+            <a:pPr marL="0" indent="0" algn="l">
               <a:buNone/>
             </a:pPr>
             <a:r>
@@ -3863,7 +4527,10 @@
         </p:spPr>
         <p:txBody>
           <a:bodyPr/>
-          <a:p/>
+          <a:lstStyle/>
+          <a:p>
+            <a:endParaRPr/>
+          </a:p>
         </p:txBody>
       </p:sp>
       <p:sp>
@@ -3890,7 +4557,10 @@
         </p:spPr>
         <p:txBody>
           <a:bodyPr/>
-          <a:p/>
+          <a:lstStyle/>
+          <a:p>
+            <a:endParaRPr/>
+          </a:p>
         </p:txBody>
       </p:sp>
       <p:sp>
@@ -3914,7 +4584,7 @@
           <a:bodyPr wrap="square" lIns="0" tIns="0" rIns="0" bIns="0" rtlCol="0" anchor="ctr"/>
           <a:lstStyle/>
           <a:p>
-            <a:pPr indent="0" marL="0">
+            <a:pPr marL="0" indent="0">
               <a:buNone/>
             </a:pPr>
             <a:r>
@@ -3953,7 +4623,7 @@
           <a:bodyPr wrap="square" lIns="0" tIns="0" rIns="0" bIns="0" rtlCol="0" anchor="ctr"/>
           <a:lstStyle/>
           <a:p>
-            <a:pPr indent="0" marL="0">
+            <a:pPr marL="0" indent="0">
               <a:buNone/>
             </a:pPr>
             <a:r>
@@ -3992,7 +4662,7 @@
           <a:bodyPr wrap="square" lIns="0" tIns="0" rIns="0" bIns="0" rtlCol="0" anchor="t"/>
           <a:lstStyle/>
           <a:p>
-            <a:pPr indent="0" marL="0">
+            <a:pPr marL="0" indent="0">
               <a:buNone/>
             </a:pPr>
             <a:r>
@@ -4031,7 +4701,7 @@
           <a:bodyPr wrap="square" lIns="0" tIns="0" rIns="0" bIns="0" rtlCol="0" anchor="t"/>
           <a:lstStyle/>
           <a:p>
-            <a:pPr indent="0" marL="0">
+            <a:pPr marL="0" indent="0">
               <a:buNone/>
             </a:pPr>
             <a:r>
@@ -4075,7 +4745,10 @@
         </p:spPr>
         <p:txBody>
           <a:bodyPr/>
-          <a:p/>
+          <a:lstStyle/>
+          <a:p>
+            <a:endParaRPr/>
+          </a:p>
         </p:txBody>
       </p:sp>
       <p:sp>
@@ -4102,7 +4775,10 @@
         </p:spPr>
         <p:txBody>
           <a:bodyPr/>
-          <a:p/>
+          <a:lstStyle/>
+          <a:p>
+            <a:endParaRPr/>
+          </a:p>
         </p:txBody>
       </p:sp>
       <p:sp>
@@ -4126,7 +4802,7 @@
           <a:bodyPr wrap="square" lIns="0" tIns="0" rIns="0" bIns="0" rtlCol="0" anchor="ctr"/>
           <a:lstStyle/>
           <a:p>
-            <a:pPr indent="0" marL="0">
+            <a:pPr marL="0" indent="0">
               <a:buNone/>
             </a:pPr>
             <a:r>
@@ -4165,7 +4841,7 @@
           <a:bodyPr wrap="square" lIns="0" tIns="0" rIns="0" bIns="0" rtlCol="0" anchor="ctr"/>
           <a:lstStyle/>
           <a:p>
-            <a:pPr indent="0" marL="0">
+            <a:pPr marL="0" indent="0">
               <a:buNone/>
             </a:pPr>
             <a:r>
@@ -4204,11 +4880,11 @@
           <a:bodyPr wrap="square" lIns="0" tIns="0" rIns="0" bIns="0" rtlCol="0" anchor="t"/>
           <a:lstStyle/>
           <a:p>
-            <a:pPr indent="0" marL="0">
+            <a:pPr marL="0" indent="0">
               <a:buNone/>
             </a:pPr>
             <a:r>
-              <a:rPr lang="en-US" sz="1400" dirty="0">
+              <a:rPr lang="en-US" sz="1200" dirty="0">
                 <a:solidFill>
                   <a:srgbClr val="1F2933"/>
                 </a:solidFill>
@@ -4218,7 +4894,7 @@
               </a:rPr>
               <a:t>You said: “When a file arrives twice we reprocess and revenue is counted twice... I have no good way to test a change before it goes live.”</a:t>
             </a:r>
-            <a:endParaRPr lang="en-US" sz="1400" dirty="0"/>
+            <a:endParaRPr lang="en-US" sz="1200" dirty="0"/>
           </a:p>
         </p:txBody>
       </p:sp>
@@ -4243,7 +4919,7 @@
           <a:bodyPr wrap="square" lIns="0" tIns="0" rIns="0" bIns="0" rtlCol="0" anchor="t"/>
           <a:lstStyle/>
           <a:p>
-            <a:pPr indent="0" marL="0">
+            <a:pPr marL="0" indent="0">
               <a:buNone/>
             </a:pPr>
             <a:r>
@@ -4287,7 +4963,10 @@
         </p:spPr>
         <p:txBody>
           <a:bodyPr/>
-          <a:p/>
+          <a:lstStyle/>
+          <a:p>
+            <a:endParaRPr/>
+          </a:p>
         </p:txBody>
       </p:sp>
       <p:sp>
@@ -4314,7 +4993,10 @@
         </p:spPr>
         <p:txBody>
           <a:bodyPr/>
-          <a:p/>
+          <a:lstStyle/>
+          <a:p>
+            <a:endParaRPr/>
+          </a:p>
         </p:txBody>
       </p:sp>
       <p:sp>
@@ -4338,7 +5020,7 @@
           <a:bodyPr wrap="square" lIns="0" tIns="0" rIns="0" bIns="0" rtlCol="0" anchor="ctr"/>
           <a:lstStyle/>
           <a:p>
-            <a:pPr indent="0" marL="0">
+            <a:pPr marL="0" indent="0">
               <a:buNone/>
             </a:pPr>
             <a:r>
@@ -4364,7 +5046,7 @@
         </p:nvSpPr>
         <p:spPr>
           <a:xfrm>
-            <a:off x="6217920" y="1783080"/>
+            <a:off x="6217920" y="1826625"/>
             <a:ext cx="2194560" cy="274320"/>
           </a:xfrm>
           <a:prstGeom prst="rect">
@@ -4377,7 +5059,7 @@
           <a:bodyPr wrap="square" lIns="0" tIns="0" rIns="0" bIns="0" rtlCol="0" anchor="ctr"/>
           <a:lstStyle/>
           <a:p>
-            <a:pPr indent="0" marL="0">
+            <a:pPr marL="0" indent="0">
               <a:buNone/>
             </a:pPr>
             <a:r>
@@ -4416,7 +5098,7 @@
           <a:bodyPr wrap="square" lIns="0" tIns="0" rIns="0" bIns="0" rtlCol="0" anchor="t"/>
           <a:lstStyle/>
           <a:p>
-            <a:pPr indent="0" marL="0">
+            <a:pPr marL="0" indent="0">
               <a:buNone/>
             </a:pPr>
             <a:r>
@@ -4455,7 +5137,7 @@
           <a:bodyPr wrap="square" lIns="0" tIns="0" rIns="0" bIns="0" rtlCol="0" anchor="t"/>
           <a:lstStyle/>
           <a:p>
-            <a:pPr indent="0" marL="0">
+            <a:pPr marL="0" indent="0">
               <a:buNone/>
             </a:pPr>
             <a:r>
@@ -4494,7 +5176,7 @@
           <a:bodyPr wrap="square" lIns="0" tIns="0" rIns="0" bIns="0" rtlCol="0" anchor="ctr"/>
           <a:lstStyle/>
           <a:p>
-            <a:pPr indent="0" marL="0">
+            <a:pPr marL="0" indent="0">
               <a:buNone/>
             </a:pPr>
             <a:r>
@@ -4532,7 +5214,7 @@
           </a:prstGeom>
           <a:extLst>
             <a:ext uri="{C572A759-6A51-4108-AA02-DFA0A04FC94B}">
-              <ma14:wrappingTextBoxFlag xmlns:ma14="http://schemas.microsoft.com/office/mac/drawingml/2011/main" val="0"/>
+              <ma14:wrappingTextBoxFlag xmlns:ma14="http://schemas.microsoft.com/office/mac/drawingml/2011/main" xmlns="" val="0"/>
             </a:ext>
           </a:extLst>
         </p:spPr>
@@ -4550,7 +5232,7 @@
           <a:p>
             <a:pPr algn="l"/>
             <a:fld id="{F7021451-1387-4CA6-816F-3879F97B5CBC}" type="slidenum">
-              <a:rPr b="0" lang="en-US"/>
+              <a:rPr lang="en-US" b="0"/>
               <a:t>2</a:t>
             </a:fld>
             <a:endParaRPr lang="en-US"/>
@@ -4585,9 +5267,11 @@
       <p:sp>
         <p:nvSpPr>
           <p:cNvPr id="2" name="Text 0"/>
-          <p:cNvSpPr/>
+          <p:cNvSpPr>
+            <a:spLocks noGrp="1"/>
+          </p:cNvSpPr>
           <p:nvPr>
-            <p:ph idx="100" type="title" hasCustomPrompt="1"/>
+            <p:ph type="title" idx="100" hasCustomPrompt="1"/>
           </p:nvPr>
         </p:nvSpPr>
         <p:spPr>
@@ -4605,7 +5289,7 @@
           <a:bodyPr wrap="square" lIns="0" tIns="0" rIns="0" bIns="0" rtlCol="0" anchor="ctr"/>
           <a:lstStyle/>
           <a:p>
-            <a:pPr algn="l" indent="0" marL="0">
+            <a:pPr marL="0" indent="0" algn="l">
               <a:buNone/>
             </a:pPr>
             <a:r>
@@ -4632,24 +5316,48 @@
           <p:nvPr>
             <p:extLst>
               <p:ext uri="{D42A27DB-BD31-4B8C-83A1-F6EECF244321}">
-                <p14:modId xmlns:p14="http://schemas.microsoft.com/office/powerpoint/2010/main" val="1579011935"/>
+                <p14:modId xmlns:p14="http://schemas.microsoft.com/office/powerpoint/2010/main" val="3194559092"/>
               </p:ext>
             </p:extLst>
           </p:nvPr>
         </p:nvGraphicFramePr>
         <p:xfrm>
-          <a:off x="548640" y="1280160"/>
-          <a:ext cx="8046720" cy="914400"/>
+          <a:off x="460149" y="1030224"/>
+          <a:ext cx="8046720" cy="3227832"/>
         </p:xfrm>
         <a:graphic>
           <a:graphicData uri="http://schemas.openxmlformats.org/drawingml/2006/table">
             <a:tbl>
               <a:tblPr/>
               <a:tblGrid>
-                <a:gridCol w="1554480"/>
-                <a:gridCol w="1920240"/>
-                <a:gridCol w="1920240"/>
-                <a:gridCol w="2651760"/>
+                <a:gridCol w="1554480">
+                  <a:extLst>
+                    <a:ext uri="{9D8B030D-6E8A-4147-A177-3AD203B41FA5}">
+                      <a16:colId xmlns:a16="http://schemas.microsoft.com/office/drawing/2014/main" val="20000"/>
+                    </a:ext>
+                  </a:extLst>
+                </a:gridCol>
+                <a:gridCol w="1920240">
+                  <a:extLst>
+                    <a:ext uri="{9D8B030D-6E8A-4147-A177-3AD203B41FA5}">
+                      <a16:colId xmlns:a16="http://schemas.microsoft.com/office/drawing/2014/main" val="20001"/>
+                    </a:ext>
+                  </a:extLst>
+                </a:gridCol>
+                <a:gridCol w="1920240">
+                  <a:extLst>
+                    <a:ext uri="{9D8B030D-6E8A-4147-A177-3AD203B41FA5}">
+                      <a16:colId xmlns:a16="http://schemas.microsoft.com/office/drawing/2014/main" val="20002"/>
+                    </a:ext>
+                  </a:extLst>
+                </a:gridCol>
+                <a:gridCol w="2651760">
+                  <a:extLst>
+                    <a:ext uri="{9D8B030D-6E8A-4147-A177-3AD203B41FA5}">
+                      <a16:colId xmlns:a16="http://schemas.microsoft.com/office/drawing/2014/main" val="20003"/>
+                    </a:ext>
+                  </a:extLst>
+                </a:gridCol>
               </a:tblGrid>
               <a:tr h="411480">
                 <a:tc>
@@ -4657,18 +5365,18 @@
                     <a:bodyPr/>
                     <a:lstStyle/>
                     <a:p>
-                      <a:pPr indent="0" marL="0">
+                      <a:pPr marL="0" indent="0">
                         <a:buNone/>
                       </a:pPr>
                       <a:r>
-                        <a:rPr lang="en-US" sz="1300" b="1" dirty="0">
+                        <a:rPr lang="en-US" sz="1200" b="1" dirty="0">
                           <a:solidFill>
                             <a:srgbClr val="FFFFFF"/>
                           </a:solidFill>
                         </a:rPr>
                         <a:t>Who</a:t>
                       </a:r>
-                      <a:endParaRPr lang="en-US" sz="1300" dirty="0"/>
+                      <a:endParaRPr lang="en-US" sz="1200" dirty="0"/>
                     </a:p>
                   </a:txBody>
                   <a:tcPr marL="73152" marR="73152" marT="73152" marB="73152" anchor="ctr">
@@ -4718,18 +5426,18 @@
                     <a:bodyPr/>
                     <a:lstStyle/>
                     <a:p>
-                      <a:pPr indent="0" marL="0">
+                      <a:pPr marL="0" indent="0">
                         <a:buNone/>
                       </a:pPr>
                       <a:r>
-                        <a:rPr lang="en-US" sz="1300" b="1" dirty="0">
+                        <a:rPr lang="en-US" sz="1200" b="1" dirty="0">
                           <a:solidFill>
                             <a:srgbClr val="FFFFFF"/>
                           </a:solidFill>
                         </a:rPr>
                         <a:t>Today</a:t>
                       </a:r>
-                      <a:endParaRPr lang="en-US" sz="1300" dirty="0"/>
+                      <a:endParaRPr lang="en-US" sz="1200" dirty="0"/>
                     </a:p>
                   </a:txBody>
                   <a:tcPr marL="73152" marR="73152" marT="73152" marB="73152" anchor="ctr">
@@ -4779,18 +5487,18 @@
                     <a:bodyPr/>
                     <a:lstStyle/>
                     <a:p>
-                      <a:pPr indent="0" marL="0">
+                      <a:pPr marL="0" indent="0">
                         <a:buNone/>
                       </a:pPr>
                       <a:r>
-                        <a:rPr lang="en-US" sz="1300" b="1" dirty="0">
+                        <a:rPr lang="en-US" sz="1200" b="1" dirty="0">
                           <a:solidFill>
                             <a:srgbClr val="FFFFFF"/>
                           </a:solidFill>
                         </a:rPr>
                         <a:t>With this</a:t>
                       </a:r>
-                      <a:endParaRPr lang="en-US" sz="1300" dirty="0"/>
+                      <a:endParaRPr lang="en-US" sz="1200" dirty="0"/>
                     </a:p>
                   </a:txBody>
                   <a:tcPr marL="73152" marR="73152" marT="73152" marB="73152" anchor="ctr">
@@ -4840,18 +5548,18 @@
                     <a:bodyPr/>
                     <a:lstStyle/>
                     <a:p>
-                      <a:pPr indent="0" marL="0">
+                      <a:pPr marL="0" indent="0">
                         <a:buNone/>
                       </a:pPr>
                       <a:r>
-                        <a:rPr lang="en-US" sz="1300" b="1" dirty="0">
+                        <a:rPr lang="en-US" sz="1200" b="1" dirty="0">
                           <a:solidFill>
                             <a:srgbClr val="FFFFFF"/>
                           </a:solidFill>
                         </a:rPr>
                         <a:t>Business value, and how we will know</a:t>
                       </a:r>
-                      <a:endParaRPr lang="en-US" sz="1300" dirty="0"/>
+                      <a:endParaRPr lang="en-US" sz="1200" dirty="0"/>
                     </a:p>
                   </a:txBody>
                   <a:tcPr marL="73152" marR="73152" marT="73152" marB="73152" anchor="ctr">
@@ -4896,6 +5604,11 @@
                     </a:solidFill>
                   </a:tcPr>
                 </a:tc>
+                <a:extLst>
+                  <a:ext uri="{0D108BD9-81ED-4DB2-BD59-A6C34878D82A}">
+                    <a16:rowId xmlns:a16="http://schemas.microsoft.com/office/drawing/2014/main" val="10000"/>
+                  </a:ext>
+                </a:extLst>
               </a:tr>
               <a:tr h="640080">
                 <a:tc>
@@ -4903,18 +5616,18 @@
                     <a:bodyPr/>
                     <a:lstStyle/>
                     <a:p>
-                      <a:pPr indent="0" marL="0">
+                      <a:pPr marL="0" indent="0">
                         <a:buNone/>
                       </a:pPr>
                       <a:r>
-                        <a:rPr lang="en-US" sz="1300" b="1" dirty="0">
+                        <a:rPr lang="en-US" sz="1200" b="1" dirty="0">
                           <a:solidFill>
                             <a:srgbClr val="1F2933"/>
                           </a:solidFill>
                         </a:rPr>
                         <a:t>Executive</a:t>
                       </a:r>
-                      <a:endParaRPr lang="en-US" sz="1300" dirty="0"/>
+                      <a:endParaRPr lang="en-US" sz="1200" dirty="0"/>
                     </a:p>
                   </a:txBody>
                   <a:tcPr marL="73152" marR="73152" marT="73152" marB="73152" anchor="ctr">
@@ -4964,18 +5677,18 @@
                     <a:bodyPr/>
                     <a:lstStyle/>
                     <a:p>
-                      <a:pPr indent="0" marL="0">
+                      <a:pPr marL="0" indent="0">
                         <a:buNone/>
                       </a:pPr>
                       <a:r>
-                        <a:rPr lang="en-US" sz="1300" dirty="0">
+                        <a:rPr lang="en-US" sz="1200" dirty="0">
                           <a:solidFill>
                             <a:srgbClr val="1F2933"/>
                           </a:solidFill>
                         </a:rPr>
                         <a:t>A different number every time I ask for loyalty retention or margin</a:t>
                       </a:r>
-                      <a:endParaRPr lang="en-US" sz="1300" dirty="0"/>
+                      <a:endParaRPr lang="en-US" sz="1200" dirty="0"/>
                     </a:p>
                   </a:txBody>
                   <a:tcPr marL="73152" marR="73152" marT="73152" marB="73152" anchor="ctr">
@@ -5025,18 +5738,18 @@
                     <a:bodyPr/>
                     <a:lstStyle/>
                     <a:p>
-                      <a:pPr indent="0" marL="0">
+                      <a:pPr marL="0" indent="0">
                         <a:buNone/>
                       </a:pPr>
                       <a:r>
-                        <a:rPr lang="en-US" sz="1300" dirty="0">
+                        <a:rPr lang="en-US" sz="1200" dirty="0">
                           <a:solidFill>
                             <a:srgbClr val="1F2933"/>
                           </a:solidFill>
                         </a:rPr>
                         <a:t>One governed margin definition (30.83%) and one loyalty retention curve, from the same gold tables every time</a:t>
                       </a:r>
-                      <a:endParaRPr lang="en-US" sz="1300" dirty="0"/>
+                      <a:endParaRPr lang="en-US" sz="1200" dirty="0"/>
                     </a:p>
                   </a:txBody>
                   <a:tcPr marL="73152" marR="73152" marT="73152" marB="73152" anchor="ctr">
@@ -5086,18 +5799,18 @@
                     <a:bodyPr/>
                     <a:lstStyle/>
                     <a:p>
-                      <a:pPr indent="0" marL="0">
+                      <a:pPr marL="0" indent="0">
                         <a:buNone/>
                       </a:pPr>
                       <a:r>
-                        <a:rPr lang="en-US" sz="1300" dirty="0">
+                        <a:rPr lang="en-US" sz="1200" dirty="0">
                           <a:solidFill>
                             <a:srgbClr val="1F2933"/>
                           </a:solidFill>
                         </a:rPr>
                         <a:t>One number the board can trust: measured by the margin rate reading the same on every page</a:t>
                       </a:r>
-                      <a:endParaRPr lang="en-US" sz="1300" dirty="0"/>
+                      <a:endParaRPr lang="en-US" sz="1200" dirty="0"/>
                     </a:p>
                   </a:txBody>
                   <a:tcPr marL="73152" marR="73152" marT="73152" marB="73152" anchor="ctr">
@@ -5142,6 +5855,11 @@
                     </a:solidFill>
                   </a:tcPr>
                 </a:tc>
+                <a:extLst>
+                  <a:ext uri="{0D108BD9-81ED-4DB2-BD59-A6C34878D82A}">
+                    <a16:rowId xmlns:a16="http://schemas.microsoft.com/office/drawing/2014/main" val="10001"/>
+                  </a:ext>
+                </a:extLst>
               </a:tr>
               <a:tr h="640080">
                 <a:tc>
@@ -5149,18 +5867,18 @@
                     <a:bodyPr/>
                     <a:lstStyle/>
                     <a:p>
-                      <a:pPr indent="0" marL="0">
+                      <a:pPr marL="0" indent="0">
                         <a:buNone/>
                       </a:pPr>
                       <a:r>
-                        <a:rPr lang="en-US" sz="1300" b="1" dirty="0">
+                        <a:rPr lang="en-US" sz="1200" b="1" dirty="0">
                           <a:solidFill>
                             <a:srgbClr val="1F2933"/>
                           </a:solidFill>
                         </a:rPr>
                         <a:t>Technical leader</a:t>
                       </a:r>
-                      <a:endParaRPr lang="en-US" sz="1300" dirty="0"/>
+                      <a:endParaRPr lang="en-US" sz="1200" dirty="0"/>
                     </a:p>
                   </a:txBody>
                   <a:tcPr marL="73152" marR="73152" marT="73152" marB="73152" anchor="ctr">
@@ -5210,18 +5928,18 @@
                     <a:bodyPr/>
                     <a:lstStyle/>
                     <a:p>
-                      <a:pPr indent="0" marL="0">
+                      <a:pPr marL="0" indent="0">
                         <a:buNone/>
                       </a:pPr>
                       <a:r>
-                        <a:rPr lang="en-US" sz="1300" dirty="0">
+                        <a:rPr lang="en-US" sz="1200" dirty="0">
                           <a:solidFill>
                             <a:srgbClr val="1F2933"/>
                           </a:solidFill>
                         </a:rPr>
                         <a:t>A file landing twice means revenue counted twice; changes reach production untested</a:t>
                       </a:r>
-                      <a:endParaRPr lang="en-US" sz="1300" dirty="0"/>
+                      <a:endParaRPr lang="en-US" sz="1200" dirty="0"/>
                     </a:p>
                   </a:txBody>
                   <a:tcPr marL="73152" marR="73152" marT="73152" marB="73152" anchor="ctr">
@@ -5271,18 +5989,18 @@
                     <a:bodyPr/>
                     <a:lstStyle/>
                     <a:p>
-                      <a:pPr indent="0" marL="0">
+                      <a:pPr marL="0" indent="0">
                         <a:buNone/>
                       </a:pPr>
                       <a:r>
-                        <a:rPr lang="en-US" sz="1300" dirty="0">
+                        <a:rPr lang="en-US" sz="1200" dirty="0">
                           <a:solidFill>
                             <a:srgbClr val="1F2933"/>
                           </a:solidFill>
                         </a:rPr>
                         <a:t>A pipeline that counts and reconciles duplicates, late arrivals and bad rows automatically</a:t>
                       </a:r>
-                      <a:endParaRPr lang="en-US" sz="1300" dirty="0"/>
+                      <a:endParaRPr lang="en-US" sz="1200" dirty="0"/>
                     </a:p>
                   </a:txBody>
                   <a:tcPr marL="73152" marR="73152" marT="73152" marB="73152" anchor="ctr">
@@ -5332,18 +6050,18 @@
                     <a:bodyPr/>
                     <a:lstStyle/>
                     <a:p>
-                      <a:pPr indent="0" marL="0">
+                      <a:pPr marL="0" indent="0">
                         <a:buNone/>
                       </a:pPr>
                       <a:r>
-                        <a:rPr lang="en-US" sz="1300" dirty="0">
+                        <a:rPr lang="en-US" sz="1200" dirty="0">
                           <a:solidFill>
                             <a:srgbClr val="1F2933"/>
                           </a:solidFill>
                         </a:rPr>
                         <a:t>Safe reprocessing and a way to test changes: measured by every run reconciling (bronze = silver + quarantine + duplicates removed) on our run</a:t>
                       </a:r>
-                      <a:endParaRPr lang="en-US" sz="1300" dirty="0"/>
+                      <a:endParaRPr lang="en-US" sz="1200" dirty="0"/>
                     </a:p>
                   </a:txBody>
                   <a:tcPr marL="73152" marR="73152" marT="73152" marB="73152" anchor="ctr">
@@ -5388,6 +6106,11 @@
                     </a:solidFill>
                   </a:tcPr>
                 </a:tc>
+                <a:extLst>
+                  <a:ext uri="{0D108BD9-81ED-4DB2-BD59-A6C34878D82A}">
+                    <a16:rowId xmlns:a16="http://schemas.microsoft.com/office/drawing/2014/main" val="10002"/>
+                  </a:ext>
+                </a:extLst>
               </a:tr>
               <a:tr h="640080">
                 <a:tc>
@@ -5395,18 +6118,18 @@
                     <a:bodyPr/>
                     <a:lstStyle/>
                     <a:p>
-                      <a:pPr indent="0" marL="0">
+                      <a:pPr marL="0" indent="0">
                         <a:buNone/>
                       </a:pPr>
                       <a:r>
-                        <a:rPr lang="en-US" sz="1300" b="1" dirty="0">
+                        <a:rPr lang="en-US" sz="1200" b="1" dirty="0">
                           <a:solidFill>
                             <a:srgbClr val="1F2933"/>
                           </a:solidFill>
                         </a:rPr>
                         <a:t>Business / analytics</a:t>
                       </a:r>
-                      <a:endParaRPr lang="en-US" sz="1300" dirty="0"/>
+                      <a:endParaRPr lang="en-US" sz="1200" dirty="0"/>
                     </a:p>
                   </a:txBody>
                   <a:tcPr marL="73152" marR="73152" marT="73152" marB="73152" anchor="ctr">
@@ -5456,18 +6179,18 @@
                     <a:bodyPr/>
                     <a:lstStyle/>
                     <a:p>
-                      <a:pPr indent="0" marL="0">
+                      <a:pPr marL="0" indent="0">
                         <a:buNone/>
                       </a:pPr>
                       <a:r>
-                        <a:rPr lang="en-US" sz="1300" dirty="0">
+                        <a:rPr lang="en-US" sz="1200" dirty="0">
                           <a:solidFill>
                             <a:srgbClr val="1F2933"/>
                           </a:solidFill>
                         </a:rPr>
                         <a:t>Planning the next peak six weeks out, guessing which products stock out and which promotions to repeat</a:t>
                       </a:r>
-                      <a:endParaRPr lang="en-US" sz="1300" dirty="0"/>
+                      <a:endParaRPr lang="en-US" sz="1200" dirty="0"/>
                     </a:p>
                   </a:txBody>
                   <a:tcPr marL="73152" marR="73152" marT="73152" marB="73152" anchor="ctr">
@@ -5517,18 +6240,18 @@
                     <a:bodyPr/>
                     <a:lstStyle/>
                     <a:p>
-                      <a:pPr indent="0" marL="0">
+                      <a:pPr marL="0" indent="0">
                         <a:buNone/>
                       </a:pPr>
                       <a:r>
-                        <a:rPr lang="en-US" sz="1300" dirty="0">
+                        <a:rPr lang="en-US" sz="1200" dirty="0">
                           <a:solidFill>
                             <a:srgbClr val="1F2933"/>
                           </a:solidFill>
                         </a:rPr>
                         <a:t>Stock-out exposure by category (ESTIMATE) and a verdict on every promotion, ahead of the peak</a:t>
                       </a:r>
-                      <a:endParaRPr lang="en-US" sz="1300" dirty="0"/>
+                      <a:endParaRPr lang="en-US" sz="1200" dirty="0"/>
                     </a:p>
                   </a:txBody>
                   <a:tcPr marL="73152" marR="73152" marT="73152" marB="73152" anchor="ctr">
@@ -5578,18 +6301,18 @@
                     <a:bodyPr/>
                     <a:lstStyle/>
                     <a:p>
-                      <a:pPr indent="0" marL="0">
+                      <a:pPr marL="0" indent="0">
                         <a:buNone/>
                       </a:pPr>
                       <a:r>
-                        <a:rPr lang="en-US" sz="1300" dirty="0">
+                        <a:rPr lang="en-US" sz="1200" dirty="0">
                           <a:solidFill>
                             <a:srgbClr val="1F2933"/>
                           </a:solidFill>
                         </a:rPr>
                         <a:t>Decisions made sooner, before the peak: measured by promotion verdicts available within days of a promotion ending</a:t>
                       </a:r>
-                      <a:endParaRPr lang="en-US" sz="1300" dirty="0"/>
+                      <a:endParaRPr lang="en-US" sz="1200" dirty="0"/>
                     </a:p>
                   </a:txBody>
                   <a:tcPr marL="73152" marR="73152" marT="73152" marB="73152" anchor="ctr">
@@ -5634,6 +6357,11 @@
                     </a:solidFill>
                   </a:tcPr>
                 </a:tc>
+                <a:extLst>
+                  <a:ext uri="{0D108BD9-81ED-4DB2-BD59-A6C34878D82A}">
+                    <a16:rowId xmlns:a16="http://schemas.microsoft.com/office/drawing/2014/main" val="10003"/>
+                  </a:ext>
+                </a:extLst>
               </a:tr>
             </a:tbl>
           </a:graphicData>
@@ -5641,13 +6369,13 @@
       </p:graphicFrame>
       <p:sp>
         <p:nvSpPr>
-          <p:cNvPr id="4" name="Text 1"/>
+          <p:cNvPr id="3" name="Text 1"/>
           <p:cNvSpPr txBox="1"/>
           <p:nvPr/>
         </p:nvSpPr>
         <p:spPr>
           <a:xfrm>
-            <a:off x="548640" y="3840480"/>
+            <a:off x="450317" y="4271919"/>
             <a:ext cx="8046720" cy="457200"/>
           </a:xfrm>
           <a:prstGeom prst="rect">
@@ -5660,7 +6388,7 @@
           <a:bodyPr wrap="square" lIns="0" tIns="0" rIns="0" bIns="0" rtlCol="0" anchor="ctr"/>
           <a:lstStyle/>
           <a:p>
-            <a:pPr indent="0" marL="0">
+            <a:pPr marL="0" indent="0">
               <a:buNone/>
             </a:pPr>
             <a:r>
@@ -5699,7 +6427,7 @@
           <a:bodyPr wrap="square" lIns="0" tIns="0" rIns="0" bIns="0" rtlCol="0" anchor="ctr"/>
           <a:lstStyle/>
           <a:p>
-            <a:pPr indent="0" marL="0">
+            <a:pPr marL="0" indent="0">
               <a:buNone/>
             </a:pPr>
             <a:r>
@@ -5737,7 +6465,7 @@
           </a:prstGeom>
           <a:extLst>
             <a:ext uri="{C572A759-6A51-4108-AA02-DFA0A04FC94B}">
-              <ma14:wrappingTextBoxFlag xmlns:ma14="http://schemas.microsoft.com/office/mac/drawingml/2011/main" val="0"/>
+              <ma14:wrappingTextBoxFlag xmlns:ma14="http://schemas.microsoft.com/office/mac/drawingml/2011/main" xmlns="" val="0"/>
             </a:ext>
           </a:extLst>
         </p:spPr>
@@ -5755,7 +6483,7 @@
           <a:p>
             <a:pPr algn="l"/>
             <a:fld id="{F7021451-1387-4CA6-816F-3879F97B5CBC}" type="slidenum">
-              <a:rPr b="0" lang="en-US"/>
+              <a:rPr lang="en-US" b="0"/>
               <a:t>3</a:t>
             </a:fld>
             <a:endParaRPr lang="en-US"/>
@@ -5790,9 +6518,11 @@
       <p:sp>
         <p:nvSpPr>
           <p:cNvPr id="2" name="Text 0"/>
-          <p:cNvSpPr/>
+          <p:cNvSpPr>
+            <a:spLocks noGrp="1"/>
+          </p:cNvSpPr>
           <p:nvPr>
-            <p:ph idx="100" type="title" hasCustomPrompt="1"/>
+            <p:ph type="title" idx="100" hasCustomPrompt="1"/>
           </p:nvPr>
         </p:nvSpPr>
         <p:spPr>
@@ -5810,7 +6540,7 @@
           <a:bodyPr wrap="square" lIns="0" tIns="0" rIns="0" bIns="0" rtlCol="0" anchor="ctr"/>
           <a:lstStyle/>
           <a:p>
-            <a:pPr algn="l" indent="0" marL="0">
+            <a:pPr marL="0" indent="0" algn="l">
               <a:buNone/>
             </a:pPr>
             <a:r>
@@ -5854,7 +6584,10 @@
         </p:spPr>
         <p:txBody>
           <a:bodyPr/>
-          <a:p/>
+          <a:lstStyle/>
+          <a:p>
+            <a:endParaRPr/>
+          </a:p>
         </p:txBody>
       </p:sp>
       <p:sp>
@@ -5878,7 +6611,7 @@
           <a:bodyPr wrap="square" lIns="0" tIns="0" rIns="0" bIns="0" rtlCol="0" anchor="ctr"/>
           <a:lstStyle/>
           <a:p>
-            <a:pPr algn="ctr" indent="0" marL="0">
+            <a:pPr marL="0" indent="0" algn="ctr">
               <a:buNone/>
             </a:pPr>
             <a:r>
@@ -5917,11 +6650,11 @@
           <a:bodyPr wrap="square" lIns="0" tIns="0" rIns="0" bIns="0" rtlCol="0" anchor="ctr"/>
           <a:lstStyle/>
           <a:p>
-            <a:pPr algn="ctr" indent="0" marL="0">
+            <a:pPr marL="0" indent="0" algn="ctr">
               <a:buNone/>
             </a:pPr>
             <a:r>
-              <a:rPr lang="en-US" sz="1200" dirty="0">
+              <a:rPr lang="en-US" sz="1100" dirty="0">
                 <a:solidFill>
                   <a:srgbClr val="6B7280"/>
                 </a:solidFill>
@@ -5931,7 +6664,7 @@
               </a:rPr>
               <a:t>POS daily export, weekly inventory snapshot, loyalty file, promotions calendar (assumed; all synthetic)</a:t>
             </a:r>
-            <a:endParaRPr lang="en-US" sz="1200" dirty="0"/>
+            <a:endParaRPr lang="en-US" sz="1100" dirty="0"/>
           </a:p>
         </p:txBody>
       </p:sp>
@@ -5956,7 +6689,7 @@
           <a:bodyPr wrap="square" lIns="0" tIns="0" rIns="0" bIns="0" rtlCol="0" anchor="ctr"/>
           <a:lstStyle/>
           <a:p>
-            <a:pPr indent="0" marL="0">
+            <a:pPr marL="0" indent="0">
               <a:buNone/>
             </a:pPr>
             <a:r>
@@ -5995,7 +6728,7 @@
           <a:bodyPr wrap="square" lIns="0" tIns="0" rIns="0" bIns="0" rtlCol="0" anchor="t"/>
           <a:lstStyle/>
           <a:p>
-            <a:pPr indent="0" marL="0">
+            <a:pPr marL="0" indent="0">
               <a:buNone/>
             </a:pPr>
             <a:r>
@@ -6034,7 +6767,7 @@
           <a:bodyPr wrap="square" lIns="0" tIns="0" rIns="0" bIns="0" rtlCol="0" anchor="ctr"/>
           <a:lstStyle/>
           <a:p>
-            <a:pPr algn="ctr" indent="0" marL="0">
+            <a:pPr marL="0" indent="0" algn="ctr">
               <a:buNone/>
             </a:pPr>
             <a:r>
@@ -6078,7 +6811,10 @@
         </p:spPr>
         <p:txBody>
           <a:bodyPr/>
-          <a:p/>
+          <a:lstStyle/>
+          <a:p>
+            <a:endParaRPr/>
+          </a:p>
         </p:txBody>
       </p:sp>
       <p:sp>
@@ -6102,7 +6838,7 @@
           <a:bodyPr wrap="square" lIns="0" tIns="0" rIns="0" bIns="0" rtlCol="0" anchor="ctr"/>
           <a:lstStyle/>
           <a:p>
-            <a:pPr algn="ctr" indent="0" marL="0">
+            <a:pPr marL="0" indent="0" algn="ctr">
               <a:buNone/>
             </a:pPr>
             <a:r>
@@ -6141,7 +6877,7 @@
           <a:bodyPr wrap="square" lIns="0" tIns="0" rIns="0" bIns="0" rtlCol="0" anchor="ctr"/>
           <a:lstStyle/>
           <a:p>
-            <a:pPr algn="ctr" indent="0" marL="0">
+            <a:pPr marL="0" indent="0" algn="ctr">
               <a:buNone/>
             </a:pPr>
             <a:r>
@@ -6180,7 +6916,7 @@
           <a:bodyPr wrap="square" lIns="0" tIns="0" rIns="0" bIns="0" rtlCol="0" anchor="ctr"/>
           <a:lstStyle/>
           <a:p>
-            <a:pPr indent="0" marL="0">
+            <a:pPr marL="0" indent="0">
               <a:buNone/>
             </a:pPr>
             <a:r>
@@ -6219,7 +6955,7 @@
           <a:bodyPr wrap="square" lIns="0" tIns="0" rIns="0" bIns="0" rtlCol="0" anchor="t"/>
           <a:lstStyle/>
           <a:p>
-            <a:pPr indent="0" marL="0">
+            <a:pPr marL="0" indent="0">
               <a:buNone/>
             </a:pPr>
             <a:r>
@@ -6258,7 +6994,7 @@
           <a:bodyPr wrap="square" lIns="0" tIns="0" rIns="0" bIns="0" rtlCol="0" anchor="ctr"/>
           <a:lstStyle/>
           <a:p>
-            <a:pPr algn="ctr" indent="0" marL="0">
+            <a:pPr marL="0" indent="0" algn="ctr">
               <a:buNone/>
             </a:pPr>
             <a:r>
@@ -6302,7 +7038,10 @@
         </p:spPr>
         <p:txBody>
           <a:bodyPr/>
-          <a:p/>
+          <a:lstStyle/>
+          <a:p>
+            <a:endParaRPr/>
+          </a:p>
         </p:txBody>
       </p:sp>
       <p:sp>
@@ -6326,7 +7065,7 @@
           <a:bodyPr wrap="square" lIns="0" tIns="0" rIns="0" bIns="0" rtlCol="0" anchor="ctr"/>
           <a:lstStyle/>
           <a:p>
-            <a:pPr algn="ctr" indent="0" marL="0">
+            <a:pPr marL="0" indent="0" algn="ctr">
               <a:buNone/>
             </a:pPr>
             <a:r>
@@ -6365,7 +7104,7 @@
           <a:bodyPr wrap="square" lIns="0" tIns="0" rIns="0" bIns="0" rtlCol="0" anchor="ctr"/>
           <a:lstStyle/>
           <a:p>
-            <a:pPr algn="ctr" indent="0" marL="0">
+            <a:pPr marL="0" indent="0" algn="ctr">
               <a:buNone/>
             </a:pPr>
             <a:r>
@@ -6404,7 +7143,7 @@
           <a:bodyPr wrap="square" lIns="0" tIns="0" rIns="0" bIns="0" rtlCol="0" anchor="ctr"/>
           <a:lstStyle/>
           <a:p>
-            <a:pPr indent="0" marL="0">
+            <a:pPr marL="0" indent="0">
               <a:buNone/>
             </a:pPr>
             <a:r>
@@ -6443,7 +7182,7 @@
           <a:bodyPr wrap="square" lIns="0" tIns="0" rIns="0" bIns="0" rtlCol="0" anchor="t"/>
           <a:lstStyle/>
           <a:p>
-            <a:pPr indent="0" marL="0">
+            <a:pPr marL="0" indent="0">
               <a:buNone/>
             </a:pPr>
             <a:r>
@@ -6482,7 +7221,7 @@
           <a:bodyPr wrap="square" lIns="0" tIns="0" rIns="0" bIns="0" rtlCol="0" anchor="ctr"/>
           <a:lstStyle/>
           <a:p>
-            <a:pPr algn="ctr" indent="0" marL="0">
+            <a:pPr marL="0" indent="0" algn="ctr">
               <a:buNone/>
             </a:pPr>
             <a:r>
@@ -6526,7 +7265,10 @@
         </p:spPr>
         <p:txBody>
           <a:bodyPr/>
-          <a:p/>
+          <a:lstStyle/>
+          <a:p>
+            <a:endParaRPr/>
+          </a:p>
         </p:txBody>
       </p:sp>
       <p:sp>
@@ -6550,7 +7292,7 @@
           <a:bodyPr wrap="square" lIns="0" tIns="0" rIns="0" bIns="0" rtlCol="0" anchor="ctr"/>
           <a:lstStyle/>
           <a:p>
-            <a:pPr algn="ctr" indent="0" marL="0">
+            <a:pPr marL="0" indent="0" algn="ctr">
               <a:buNone/>
             </a:pPr>
             <a:r>
@@ -6589,7 +7331,7 @@
           <a:bodyPr wrap="square" lIns="0" tIns="0" rIns="0" bIns="0" rtlCol="0" anchor="ctr"/>
           <a:lstStyle/>
           <a:p>
-            <a:pPr algn="ctr" indent="0" marL="0">
+            <a:pPr marL="0" indent="0" algn="ctr">
               <a:buNone/>
             </a:pPr>
             <a:r>
@@ -6628,7 +7370,7 @@
           <a:bodyPr wrap="square" lIns="0" tIns="0" rIns="0" bIns="0" rtlCol="0" anchor="ctr"/>
           <a:lstStyle/>
           <a:p>
-            <a:pPr indent="0" marL="0">
+            <a:pPr marL="0" indent="0">
               <a:buNone/>
             </a:pPr>
             <a:r>
@@ -6667,7 +7409,7 @@
           <a:bodyPr wrap="square" lIns="0" tIns="0" rIns="0" bIns="0" rtlCol="0" anchor="t"/>
           <a:lstStyle/>
           <a:p>
-            <a:pPr indent="0" marL="0">
+            <a:pPr marL="0" indent="0">
               <a:buNone/>
             </a:pPr>
             <a:r>
@@ -6711,7 +7453,10 @@
         </p:spPr>
         <p:txBody>
           <a:bodyPr/>
-          <a:p/>
+          <a:lstStyle/>
+          <a:p>
+            <a:endParaRPr/>
+          </a:p>
         </p:txBody>
       </p:sp>
       <p:sp>
@@ -6735,7 +7480,7 @@
           <a:bodyPr wrap="square" lIns="0" tIns="0" rIns="0" bIns="0" rtlCol="0" anchor="ctr"/>
           <a:lstStyle/>
           <a:p>
-            <a:pPr indent="0" marL="0">
+            <a:pPr marL="0" indent="0">
               <a:buNone/>
             </a:pPr>
             <a:r>
@@ -6779,7 +7524,10 @@
         </p:spPr>
         <p:txBody>
           <a:bodyPr/>
-          <a:p/>
+          <a:lstStyle/>
+          <a:p>
+            <a:endParaRPr/>
+          </a:p>
         </p:txBody>
       </p:sp>
       <p:sp>
@@ -6803,7 +7551,7 @@
           <a:bodyPr wrap="square" lIns="0" tIns="0" rIns="0" bIns="0" rtlCol="0" anchor="ctr"/>
           <a:lstStyle/>
           <a:p>
-            <a:pPr indent="0" marL="0">
+            <a:pPr marL="0" indent="0">
               <a:buNone/>
             </a:pPr>
             <a:r>
@@ -6823,7 +7571,7 @@
       </p:sp>
       <p:sp>
         <p:nvSpPr>
-          <p:cNvPr id="25" name="Slide Number Placeholder 0"/>
+          <p:cNvPr id="30" name="Slide Number Placeholder 0"/>
           <p:cNvSpPr>
             <a:spLocks noGrp="1"/>
           </p:cNvSpPr>
@@ -6841,7 +7589,7 @@
           </a:prstGeom>
           <a:extLst>
             <a:ext uri="{C572A759-6A51-4108-AA02-DFA0A04FC94B}">
-              <ma14:wrappingTextBoxFlag xmlns:ma14="http://schemas.microsoft.com/office/mac/drawingml/2011/main" val="0"/>
+              <ma14:wrappingTextBoxFlag xmlns:ma14="http://schemas.microsoft.com/office/mac/drawingml/2011/main" xmlns="" val="0"/>
             </a:ext>
           </a:extLst>
         </p:spPr>
@@ -6859,7 +7607,7 @@
           <a:p>
             <a:pPr algn="l"/>
             <a:fld id="{F7021451-1387-4CA6-816F-3879F97B5CBC}" type="slidenum">
-              <a:rPr b="0" lang="en-US"/>
+              <a:rPr lang="en-US" b="0"/>
               <a:t>4</a:t>
             </a:fld>
             <a:endParaRPr lang="en-US"/>
@@ -6894,9 +7642,11 @@
       <p:sp>
         <p:nvSpPr>
           <p:cNvPr id="2" name="Text 0"/>
-          <p:cNvSpPr/>
+          <p:cNvSpPr>
+            <a:spLocks noGrp="1"/>
+          </p:cNvSpPr>
           <p:nvPr>
-            <p:ph idx="100" type="title" hasCustomPrompt="1"/>
+            <p:ph type="title" idx="100" hasCustomPrompt="1"/>
           </p:nvPr>
         </p:nvSpPr>
         <p:spPr>
@@ -6914,7 +7664,7 @@
           <a:bodyPr wrap="square" lIns="0" tIns="0" rIns="0" bIns="0" rtlCol="0" anchor="ctr"/>
           <a:lstStyle/>
           <a:p>
-            <a:pPr algn="l" indent="0" marL="0">
+            <a:pPr marL="0" indent="0" algn="l">
               <a:buNone/>
             </a:pPr>
             <a:r>
@@ -6958,7 +7708,10 @@
         </p:spPr>
         <p:txBody>
           <a:bodyPr/>
-          <a:p/>
+          <a:lstStyle/>
+          <a:p>
+            <a:endParaRPr/>
+          </a:p>
         </p:txBody>
       </p:sp>
       <p:sp>
@@ -6985,7 +7738,10 @@
         </p:spPr>
         <p:txBody>
           <a:bodyPr/>
-          <a:p/>
+          <a:lstStyle/>
+          <a:p>
+            <a:endParaRPr/>
+          </a:p>
         </p:txBody>
       </p:sp>
       <p:sp>
@@ -7009,7 +7765,7 @@
           <a:bodyPr wrap="square" lIns="0" tIns="0" rIns="0" bIns="0" rtlCol="0" anchor="ctr"/>
           <a:lstStyle/>
           <a:p>
-            <a:pPr indent="0" marL="0">
+            <a:pPr marL="0" indent="0">
               <a:buNone/>
             </a:pPr>
             <a:r>
@@ -7048,7 +7804,7 @@
           <a:bodyPr wrap="square" lIns="0" tIns="0" rIns="0" bIns="0" rtlCol="0" anchor="ctr"/>
           <a:lstStyle/>
           <a:p>
-            <a:pPr indent="0" marL="0">
+            <a:pPr marL="0" indent="0">
               <a:buNone/>
             </a:pPr>
             <a:r>
@@ -7156,7 +7912,10 @@
         </p:spPr>
         <p:txBody>
           <a:bodyPr/>
-          <a:p/>
+          <a:lstStyle/>
+          <a:p>
+            <a:endParaRPr/>
+          </a:p>
         </p:txBody>
       </p:sp>
       <p:sp>
@@ -7183,7 +7942,10 @@
         </p:spPr>
         <p:txBody>
           <a:bodyPr/>
-          <a:p/>
+          <a:lstStyle/>
+          <a:p>
+            <a:endParaRPr/>
+          </a:p>
         </p:txBody>
       </p:sp>
       <p:sp>
@@ -7207,7 +7969,7 @@
           <a:bodyPr wrap="square" lIns="0" tIns="0" rIns="0" bIns="0" rtlCol="0" anchor="ctr"/>
           <a:lstStyle/>
           <a:p>
-            <a:pPr indent="0" marL="0">
+            <a:pPr marL="0" indent="0">
               <a:buNone/>
             </a:pPr>
             <a:r>
@@ -7246,7 +8008,7 @@
           <a:bodyPr wrap="square" lIns="0" tIns="0" rIns="0" bIns="0" rtlCol="0" anchor="ctr"/>
           <a:lstStyle/>
           <a:p>
-            <a:pPr indent="0" marL="0">
+            <a:pPr marL="0" indent="0">
               <a:buNone/>
             </a:pPr>
             <a:r>
@@ -7354,7 +8116,10 @@
         </p:spPr>
         <p:txBody>
           <a:bodyPr/>
-          <a:p/>
+          <a:lstStyle/>
+          <a:p>
+            <a:endParaRPr/>
+          </a:p>
         </p:txBody>
       </p:sp>
       <p:sp>
@@ -7381,7 +8146,10 @@
         </p:spPr>
         <p:txBody>
           <a:bodyPr/>
-          <a:p/>
+          <a:lstStyle/>
+          <a:p>
+            <a:endParaRPr/>
+          </a:p>
         </p:txBody>
       </p:sp>
       <p:sp>
@@ -7405,7 +8173,7 @@
           <a:bodyPr wrap="square" lIns="0" tIns="0" rIns="0" bIns="0" rtlCol="0" anchor="ctr"/>
           <a:lstStyle/>
           <a:p>
-            <a:pPr indent="0" marL="0">
+            <a:pPr marL="0" indent="0">
               <a:buNone/>
             </a:pPr>
             <a:r>
@@ -7444,7 +8212,7 @@
           <a:bodyPr wrap="square" lIns="0" tIns="0" rIns="0" bIns="0" rtlCol="0" anchor="ctr"/>
           <a:lstStyle/>
           <a:p>
-            <a:pPr indent="0" marL="0">
+            <a:pPr marL="0" indent="0">
               <a:buNone/>
             </a:pPr>
             <a:r>
@@ -7547,7 +8315,7 @@
           <a:bodyPr wrap="square" lIns="0" tIns="0" rIns="0" bIns="0" rtlCol="0" anchor="ctr"/>
           <a:lstStyle/>
           <a:p>
-            <a:pPr indent="0" marL="0">
+            <a:pPr marL="0" indent="0">
               <a:buNone/>
             </a:pPr>
             <a:r>
@@ -7586,7 +8354,7 @@
           <a:bodyPr wrap="square" lIns="0" tIns="0" rIns="0" bIns="0" rtlCol="0" anchor="ctr"/>
           <a:lstStyle/>
           <a:p>
-            <a:pPr indent="0" marL="0">
+            <a:pPr marL="0" indent="0">
               <a:buNone/>
             </a:pPr>
             <a:r>
@@ -7624,7 +8392,7 @@
           </a:prstGeom>
           <a:extLst>
             <a:ext uri="{C572A759-6A51-4108-AA02-DFA0A04FC94B}">
-              <ma14:wrappingTextBoxFlag xmlns:ma14="http://schemas.microsoft.com/office/mac/drawingml/2011/main" val="0"/>
+              <ma14:wrappingTextBoxFlag xmlns:ma14="http://schemas.microsoft.com/office/mac/drawingml/2011/main" xmlns="" val="0"/>
             </a:ext>
           </a:extLst>
         </p:spPr>
@@ -7642,7 +8410,7 @@
           <a:p>
             <a:pPr algn="l"/>
             <a:fld id="{F7021451-1387-4CA6-816F-3879F97B5CBC}" type="slidenum">
-              <a:rPr b="0" lang="en-US"/>
+              <a:rPr lang="en-US" b="0"/>
               <a:t>5</a:t>
             </a:fld>
             <a:endParaRPr lang="en-US"/>
@@ -7677,9 +8445,11 @@
       <p:sp>
         <p:nvSpPr>
           <p:cNvPr id="2" name="Text 0"/>
-          <p:cNvSpPr/>
+          <p:cNvSpPr>
+            <a:spLocks noGrp="1"/>
+          </p:cNvSpPr>
           <p:nvPr>
-            <p:ph idx="100" type="title" hasCustomPrompt="1"/>
+            <p:ph type="title" idx="100" hasCustomPrompt="1"/>
           </p:nvPr>
         </p:nvSpPr>
         <p:spPr>
@@ -7697,7 +8467,7 @@
           <a:bodyPr wrap="square" lIns="0" tIns="0" rIns="0" bIns="0" rtlCol="0" anchor="ctr"/>
           <a:lstStyle/>
           <a:p>
-            <a:pPr algn="l" indent="0" marL="0">
+            <a:pPr marL="0" indent="0" algn="l">
               <a:buNone/>
             </a:pPr>
             <a:r>
@@ -7739,7 +8509,10 @@
         </p:spPr>
         <p:txBody>
           <a:bodyPr/>
-          <a:p/>
+          <a:lstStyle/>
+          <a:p>
+            <a:endParaRPr/>
+          </a:p>
         </p:txBody>
       </p:sp>
       <p:sp>
@@ -7768,7 +8541,10 @@
         </p:spPr>
         <p:txBody>
           <a:bodyPr/>
-          <a:p/>
+          <a:lstStyle/>
+          <a:p>
+            <a:endParaRPr/>
+          </a:p>
         </p:txBody>
       </p:sp>
       <p:sp>
@@ -7792,7 +8568,7 @@
           <a:bodyPr wrap="square" lIns="0" tIns="0" rIns="0" bIns="0" rtlCol="0" anchor="ctr"/>
           <a:lstStyle/>
           <a:p>
-            <a:pPr indent="0" marL="0">
+            <a:pPr marL="0" indent="0">
               <a:buNone/>
             </a:pPr>
             <a:r>
@@ -7831,7 +8607,7 @@
           <a:bodyPr wrap="square" lIns="0" tIns="0" rIns="0" bIns="0" rtlCol="0" anchor="ctr"/>
           <a:lstStyle/>
           <a:p>
-            <a:pPr indent="0" marL="0">
+            <a:pPr marL="0" indent="0">
               <a:buNone/>
             </a:pPr>
             <a:r>
@@ -7870,7 +8646,7 @@
           <a:bodyPr wrap="square" lIns="0" tIns="0" rIns="0" bIns="0" rtlCol="0" anchor="ctr"/>
           <a:lstStyle/>
           <a:p>
-            <a:pPr indent="0" marL="0">
+            <a:pPr marL="0" indent="0">
               <a:buNone/>
             </a:pPr>
             <a:r>
@@ -7914,7 +8690,10 @@
         </p:spPr>
         <p:txBody>
           <a:bodyPr/>
-          <a:p/>
+          <a:lstStyle/>
+          <a:p>
+            <a:endParaRPr/>
+          </a:p>
         </p:txBody>
       </p:sp>
       <p:sp>
@@ -7938,7 +8717,7 @@
           <a:bodyPr wrap="square" lIns="0" tIns="0" rIns="0" bIns="0" rtlCol="0" anchor="ctr"/>
           <a:lstStyle/>
           <a:p>
-            <a:pPr indent="0" marL="0">
+            <a:pPr marL="0" indent="0">
               <a:buNone/>
             </a:pPr>
             <a:r>
@@ -7977,7 +8756,7 @@
           <a:bodyPr wrap="square" lIns="0" tIns="0" rIns="0" bIns="0" rtlCol="0" anchor="ctr"/>
           <a:lstStyle/>
           <a:p>
-            <a:pPr indent="0" marL="0">
+            <a:pPr marL="0" indent="0">
               <a:buNone/>
             </a:pPr>
             <a:r>
@@ -8016,7 +8795,7 @@
           <a:bodyPr wrap="square" lIns="0" tIns="0" rIns="0" bIns="0" rtlCol="0" anchor="ctr"/>
           <a:lstStyle/>
           <a:p>
-            <a:pPr indent="0" marL="0">
+            <a:pPr marL="0" indent="0">
               <a:buNone/>
             </a:pPr>
             <a:r>
@@ -8060,7 +8839,10 @@
         </p:spPr>
         <p:txBody>
           <a:bodyPr/>
-          <a:p/>
+          <a:lstStyle/>
+          <a:p>
+            <a:endParaRPr/>
+          </a:p>
         </p:txBody>
       </p:sp>
       <p:sp>
@@ -8084,7 +8866,7 @@
           <a:bodyPr wrap="square" lIns="0" tIns="0" rIns="0" bIns="0" rtlCol="0" anchor="ctr"/>
           <a:lstStyle/>
           <a:p>
-            <a:pPr indent="0" marL="0">
+            <a:pPr marL="0" indent="0">
               <a:buNone/>
             </a:pPr>
             <a:r>
@@ -8123,7 +8905,7 @@
           <a:bodyPr wrap="square" lIns="0" tIns="0" rIns="0" bIns="0" rtlCol="0" anchor="ctr"/>
           <a:lstStyle/>
           <a:p>
-            <a:pPr indent="0" marL="0">
+            <a:pPr marL="0" indent="0">
               <a:buNone/>
             </a:pPr>
             <a:r>
@@ -8162,7 +8944,7 @@
           <a:bodyPr wrap="square" lIns="0" tIns="0" rIns="0" bIns="0" rtlCol="0" anchor="ctr"/>
           <a:lstStyle/>
           <a:p>
-            <a:pPr indent="0" marL="0">
+            <a:pPr marL="0" indent="0">
               <a:buNone/>
             </a:pPr>
             <a:r>
@@ -8206,7 +8988,10 @@
         </p:spPr>
         <p:txBody>
           <a:bodyPr/>
-          <a:p/>
+          <a:lstStyle/>
+          <a:p>
+            <a:endParaRPr/>
+          </a:p>
         </p:txBody>
       </p:sp>
       <p:sp>
@@ -8230,7 +9015,7 @@
           <a:bodyPr wrap="square" lIns="0" tIns="0" rIns="0" bIns="0" rtlCol="0" anchor="ctr"/>
           <a:lstStyle/>
           <a:p>
-            <a:pPr indent="0" marL="0">
+            <a:pPr marL="0" indent="0">
               <a:buNone/>
             </a:pPr>
             <a:r>
@@ -8269,7 +9054,7 @@
           <a:bodyPr wrap="square" lIns="0" tIns="0" rIns="0" bIns="0" rtlCol="0" anchor="ctr"/>
           <a:lstStyle/>
           <a:p>
-            <a:pPr indent="0" marL="0">
+            <a:pPr marL="0" indent="0">
               <a:buNone/>
             </a:pPr>
             <a:r>
@@ -8308,7 +9093,7 @@
           <a:bodyPr wrap="square" lIns="0" tIns="0" rIns="0" bIns="0" rtlCol="0" anchor="ctr"/>
           <a:lstStyle/>
           <a:p>
-            <a:pPr indent="0" marL="0">
+            <a:pPr marL="0" indent="0">
               <a:buNone/>
             </a:pPr>
             <a:r>
@@ -8347,7 +9132,7 @@
           <a:bodyPr wrap="square" lIns="0" tIns="0" rIns="0" bIns="0" rtlCol="0" anchor="ctr"/>
           <a:lstStyle/>
           <a:p>
-            <a:pPr indent="0" marL="0">
+            <a:pPr marL="0" indent="0">
               <a:buNone/>
             </a:pPr>
             <a:r>
@@ -8385,7 +9170,7 @@
           </a:prstGeom>
           <a:extLst>
             <a:ext uri="{C572A759-6A51-4108-AA02-DFA0A04FC94B}">
-              <ma14:wrappingTextBoxFlag xmlns:ma14="http://schemas.microsoft.com/office/mac/drawingml/2011/main" val="0"/>
+              <ma14:wrappingTextBoxFlag xmlns:ma14="http://schemas.microsoft.com/office/mac/drawingml/2011/main" xmlns="" val="0"/>
             </a:ext>
           </a:extLst>
         </p:spPr>
@@ -8403,7 +9188,7 @@
           <a:p>
             <a:pPr algn="l"/>
             <a:fld id="{F7021451-1387-4CA6-816F-3879F97B5CBC}" type="slidenum">
-              <a:rPr b="0" lang="en-US"/>
+              <a:rPr lang="en-US" b="0"/>
               <a:t>6</a:t>
             </a:fld>
             <a:endParaRPr lang="en-US"/>
@@ -8438,9 +9223,11 @@
       <p:sp>
         <p:nvSpPr>
           <p:cNvPr id="2" name="Text 0"/>
-          <p:cNvSpPr/>
+          <p:cNvSpPr>
+            <a:spLocks noGrp="1"/>
+          </p:cNvSpPr>
           <p:nvPr>
-            <p:ph idx="100" type="title" hasCustomPrompt="1"/>
+            <p:ph type="title" idx="100" hasCustomPrompt="1"/>
           </p:nvPr>
         </p:nvSpPr>
         <p:spPr>
@@ -8458,7 +9245,7 @@
           <a:bodyPr wrap="square" lIns="0" tIns="0" rIns="0" bIns="0" rtlCol="0" anchor="ctr"/>
           <a:lstStyle/>
           <a:p>
-            <a:pPr algn="l" indent="0" marL="0">
+            <a:pPr marL="0" indent="0" algn="l">
               <a:buNone/>
             </a:pPr>
             <a:r>
@@ -8492,16 +9279,34 @@
         </p:nvGraphicFramePr>
         <p:xfrm>
           <a:off x="548640" y="1280160"/>
-          <a:ext cx="8046720" cy="914400"/>
+          <a:ext cx="8046720" cy="2432304"/>
         </p:xfrm>
         <a:graphic>
           <a:graphicData uri="http://schemas.openxmlformats.org/drawingml/2006/table">
             <a:tbl>
               <a:tblPr/>
               <a:tblGrid>
-                <a:gridCol w="2926080"/>
-                <a:gridCol w="2560320"/>
-                <a:gridCol w="2560320"/>
+                <a:gridCol w="2926080">
+                  <a:extLst>
+                    <a:ext uri="{9D8B030D-6E8A-4147-A177-3AD203B41FA5}">
+                      <a16:colId xmlns:a16="http://schemas.microsoft.com/office/drawing/2014/main" val="20000"/>
+                    </a:ext>
+                  </a:extLst>
+                </a:gridCol>
+                <a:gridCol w="2560320">
+                  <a:extLst>
+                    <a:ext uri="{9D8B030D-6E8A-4147-A177-3AD203B41FA5}">
+                      <a16:colId xmlns:a16="http://schemas.microsoft.com/office/drawing/2014/main" val="20001"/>
+                    </a:ext>
+                  </a:extLst>
+                </a:gridCol>
+                <a:gridCol w="2560320">
+                  <a:extLst>
+                    <a:ext uri="{9D8B030D-6E8A-4147-A177-3AD203B41FA5}">
+                      <a16:colId xmlns:a16="http://schemas.microsoft.com/office/drawing/2014/main" val="20002"/>
+                    </a:ext>
+                  </a:extLst>
+                </a:gridCol>
               </a:tblGrid>
               <a:tr h="411480">
                 <a:tc>
@@ -8509,7 +9314,7 @@
                     <a:bodyPr/>
                     <a:lstStyle/>
                     <a:p>
-                      <a:pPr indent="0" marL="0">
+                      <a:pPr marL="0" indent="0">
                         <a:buNone/>
                       </a:pPr>
                       <a:r>
@@ -8570,7 +9375,7 @@
                     <a:bodyPr/>
                     <a:lstStyle/>
                     <a:p>
-                      <a:pPr indent="0" marL="0">
+                      <a:pPr marL="0" indent="0">
                         <a:buNone/>
                       </a:pPr>
                       <a:r>
@@ -8631,7 +9436,7 @@
                     <a:bodyPr/>
                     <a:lstStyle/>
                     <a:p>
-                      <a:pPr indent="0" marL="0">
+                      <a:pPr marL="0" indent="0">
                         <a:buNone/>
                       </a:pPr>
                       <a:r>
@@ -8687,6 +9492,11 @@
                     </a:solidFill>
                   </a:tcPr>
                 </a:tc>
+                <a:extLst>
+                  <a:ext uri="{0D108BD9-81ED-4DB2-BD59-A6C34878D82A}">
+                    <a16:rowId xmlns:a16="http://schemas.microsoft.com/office/drawing/2014/main" val="10000"/>
+                  </a:ext>
+                </a:extLst>
               </a:tr>
               <a:tr h="640080">
                 <a:tc>
@@ -8694,7 +9504,7 @@
                     <a:bodyPr/>
                     <a:lstStyle/>
                     <a:p>
-                      <a:pPr indent="0" marL="0">
+                      <a:pPr marL="0" indent="0">
                         <a:buNone/>
                       </a:pPr>
                       <a:r>
@@ -8755,7 +9565,7 @@
                     <a:bodyPr/>
                     <a:lstStyle/>
                     <a:p>
-                      <a:pPr indent="0" marL="0">
+                      <a:pPr marL="0" indent="0">
                         <a:buNone/>
                       </a:pPr>
                       <a:r>
@@ -8816,7 +9626,7 @@
                     <a:bodyPr/>
                     <a:lstStyle/>
                     <a:p>
-                      <a:pPr indent="0" marL="0">
+                      <a:pPr marL="0" indent="0">
                         <a:buNone/>
                       </a:pPr>
                       <a:r>
@@ -8872,6 +9682,11 @@
                     </a:solidFill>
                   </a:tcPr>
                 </a:tc>
+                <a:extLst>
+                  <a:ext uri="{0D108BD9-81ED-4DB2-BD59-A6C34878D82A}">
+                    <a16:rowId xmlns:a16="http://schemas.microsoft.com/office/drawing/2014/main" val="10001"/>
+                  </a:ext>
+                </a:extLst>
               </a:tr>
               <a:tr h="640080">
                 <a:tc>
@@ -8879,7 +9694,7 @@
                     <a:bodyPr/>
                     <a:lstStyle/>
                     <a:p>
-                      <a:pPr indent="0" marL="0">
+                      <a:pPr marL="0" indent="0">
                         <a:buNone/>
                       </a:pPr>
                       <a:r>
@@ -8940,7 +9755,7 @@
                     <a:bodyPr/>
                     <a:lstStyle/>
                     <a:p>
-                      <a:pPr indent="0" marL="0">
+                      <a:pPr marL="0" indent="0">
                         <a:buNone/>
                       </a:pPr>
                       <a:r>
@@ -9001,7 +9816,7 @@
                     <a:bodyPr/>
                     <a:lstStyle/>
                     <a:p>
-                      <a:pPr indent="0" marL="0">
+                      <a:pPr marL="0" indent="0">
                         <a:buNone/>
                       </a:pPr>
                       <a:r>
@@ -9057,6 +9872,11 @@
                     </a:solidFill>
                   </a:tcPr>
                 </a:tc>
+                <a:extLst>
+                  <a:ext uri="{0D108BD9-81ED-4DB2-BD59-A6C34878D82A}">
+                    <a16:rowId xmlns:a16="http://schemas.microsoft.com/office/drawing/2014/main" val="10002"/>
+                  </a:ext>
+                </a:extLst>
               </a:tr>
               <a:tr h="640080">
                 <a:tc>
@@ -9064,7 +9884,7 @@
                     <a:bodyPr/>
                     <a:lstStyle/>
                     <a:p>
-                      <a:pPr indent="0" marL="0">
+                      <a:pPr marL="0" indent="0">
                         <a:buNone/>
                       </a:pPr>
                       <a:r>
@@ -9125,7 +9945,7 @@
                     <a:bodyPr/>
                     <a:lstStyle/>
                     <a:p>
-                      <a:pPr indent="0" marL="0">
+                      <a:pPr marL="0" indent="0">
                         <a:buNone/>
                       </a:pPr>
                       <a:r>
@@ -9186,7 +10006,7 @@
                     <a:bodyPr/>
                     <a:lstStyle/>
                     <a:p>
-                      <a:pPr indent="0" marL="0">
+                      <a:pPr marL="0" indent="0">
                         <a:buNone/>
                       </a:pPr>
                       <a:r>
@@ -9242,6 +10062,11 @@
                     </a:solidFill>
                   </a:tcPr>
                 </a:tc>
+                <a:extLst>
+                  <a:ext uri="{0D108BD9-81ED-4DB2-BD59-A6C34878D82A}">
+                    <a16:rowId xmlns:a16="http://schemas.microsoft.com/office/drawing/2014/main" val="10003"/>
+                  </a:ext>
+                </a:extLst>
               </a:tr>
             </a:tbl>
           </a:graphicData>
@@ -9267,7 +10092,7 @@
           </a:prstGeom>
           <a:extLst>
             <a:ext uri="{C572A759-6A51-4108-AA02-DFA0A04FC94B}">
-              <ma14:wrappingTextBoxFlag xmlns:ma14="http://schemas.microsoft.com/office/mac/drawingml/2011/main" val="0"/>
+              <ma14:wrappingTextBoxFlag xmlns:ma14="http://schemas.microsoft.com/office/mac/drawingml/2011/main" xmlns="" val="0"/>
             </a:ext>
           </a:extLst>
         </p:spPr>
@@ -9285,7 +10110,7 @@
           <a:p>
             <a:pPr algn="l"/>
             <a:fld id="{F7021451-1387-4CA6-816F-3879F97B5CBC}" type="slidenum">
-              <a:rPr b="0" lang="en-US"/>
+              <a:rPr lang="en-US" b="0"/>
               <a:t>7</a:t>
             </a:fld>
             <a:endParaRPr lang="en-US"/>
@@ -9320,15 +10145,17 @@
       <p:sp>
         <p:nvSpPr>
           <p:cNvPr id="2" name="Text 0"/>
-          <p:cNvSpPr/>
+          <p:cNvSpPr>
+            <a:spLocks noGrp="1"/>
+          </p:cNvSpPr>
           <p:nvPr>
-            <p:ph idx="100" type="title" hasCustomPrompt="1"/>
+            <p:ph type="title" idx="100" hasCustomPrompt="1"/>
           </p:nvPr>
         </p:nvSpPr>
         <p:spPr>
           <a:xfrm>
-            <a:off x="548640" y="320040"/>
-            <a:ext cx="8046720" cy="731520"/>
+            <a:off x="548640" y="114300"/>
+            <a:ext cx="8046720" cy="457200"/>
           </a:xfrm>
           <a:prstGeom prst="rect">
             <a:avLst/>
@@ -9340,7 +10167,7 @@
           <a:bodyPr wrap="square" lIns="0" tIns="0" rIns="0" bIns="0" rtlCol="0" anchor="ctr"/>
           <a:lstStyle/>
           <a:p>
-            <a:pPr algn="l" indent="0" marL="0">
+            <a:pPr marL="0" indent="0" algn="l">
               <a:buNone/>
             </a:pPr>
             <a:r>
@@ -9384,7 +10211,10 @@
         </p:spPr>
         <p:txBody>
           <a:bodyPr/>
-          <a:p/>
+          <a:lstStyle/>
+          <a:p>
+            <a:endParaRPr/>
+          </a:p>
         </p:txBody>
       </p:sp>
       <p:sp>
@@ -9408,7 +10238,7 @@
           <a:bodyPr wrap="square" lIns="0" tIns="0" rIns="0" bIns="0" rtlCol="0" anchor="ctr"/>
           <a:lstStyle/>
           <a:p>
-            <a:pPr algn="ctr" indent="0" marL="0">
+            <a:pPr marL="0" indent="0" algn="ctr">
               <a:buNone/>
             </a:pPr>
             <a:r>
@@ -9446,7 +10276,7 @@
           </a:prstGeom>
           <a:extLst>
             <a:ext uri="{C572A759-6A51-4108-AA02-DFA0A04FC94B}">
-              <ma14:wrappingTextBoxFlag xmlns:ma14="http://schemas.microsoft.com/office/mac/drawingml/2011/main" val="0"/>
+              <ma14:wrappingTextBoxFlag xmlns:ma14="http://schemas.microsoft.com/office/mac/drawingml/2011/main" xmlns="" val="0"/>
             </a:ext>
           </a:extLst>
         </p:spPr>
@@ -9464,7 +10294,7 @@
           <a:p>
             <a:pPr algn="l"/>
             <a:fld id="{F7021451-1387-4CA6-816F-3879F97B5CBC}" type="slidenum">
-              <a:rPr b="0" lang="en-US"/>
+              <a:rPr lang="en-US" b="0"/>
               <a:t>8</a:t>
             </a:fld>
             <a:endParaRPr lang="en-US"/>
@@ -9473,7 +10303,13 @@
       </p:sp>
       <p:pic>
         <p:nvPicPr>
-          <p:cNvPr id="26" name="Picture 25" descr="architecture.jpg"/>
+          <p:cNvPr id="6" name="Picture 5">
+            <a:extLst>
+              <a:ext uri="{FF2B5EF4-FFF2-40B4-BE49-F238E27FC236}">
+                <a16:creationId xmlns:a16="http://schemas.microsoft.com/office/drawing/2014/main" id="{5A1974E4-F73F-5E5C-D43B-582B5FA44A9E}"/>
+              </a:ext>
+            </a:extLst>
+          </p:cNvPr>
           <p:cNvPicPr>
             <a:picLocks noChangeAspect="1"/>
           </p:cNvPicPr>
@@ -9487,8 +10323,8 @@
         </p:blipFill>
         <p:spPr>
           <a:xfrm>
-            <a:off x="548640" y="1188720"/>
-            <a:ext cx="8046720" cy="3393387"/>
+            <a:off x="132080" y="571500"/>
+            <a:ext cx="8849360" cy="4396646"/>
           </a:xfrm>
           <a:prstGeom prst="rect">
             <a:avLst/>
@@ -9523,15 +10359,17 @@
       <p:sp>
         <p:nvSpPr>
           <p:cNvPr id="2" name="Text 0"/>
-          <p:cNvSpPr/>
+          <p:cNvSpPr>
+            <a:spLocks noGrp="1"/>
+          </p:cNvSpPr>
           <p:nvPr>
-            <p:ph idx="100" type="title" hasCustomPrompt="1"/>
+            <p:ph type="title" idx="100" hasCustomPrompt="1"/>
           </p:nvPr>
         </p:nvSpPr>
         <p:spPr>
           <a:xfrm>
-            <a:off x="548640" y="320040"/>
-            <a:ext cx="8046720" cy="731520"/>
+            <a:off x="548640" y="114300"/>
+            <a:ext cx="8046720" cy="365760"/>
           </a:xfrm>
           <a:prstGeom prst="rect">
             <a:avLst/>
@@ -9543,7 +10381,7 @@
           <a:bodyPr wrap="square" lIns="0" tIns="0" rIns="0" bIns="0" rtlCol="0" anchor="ctr"/>
           <a:lstStyle/>
           <a:p>
-            <a:pPr algn="l" indent="0" marL="0">
+            <a:pPr marL="0" indent="0" algn="l">
               <a:buNone/>
             </a:pPr>
             <a:r>
@@ -9587,7 +10425,10 @@
         </p:spPr>
         <p:txBody>
           <a:bodyPr/>
-          <a:p/>
+          <a:lstStyle/>
+          <a:p>
+            <a:endParaRPr/>
+          </a:p>
         </p:txBody>
       </p:sp>
       <p:sp>
@@ -9611,7 +10452,7 @@
           <a:bodyPr wrap="square" lIns="0" tIns="0" rIns="0" bIns="0" rtlCol="0" anchor="ctr"/>
           <a:lstStyle/>
           <a:p>
-            <a:pPr algn="ctr" indent="0" marL="0">
+            <a:pPr marL="0" indent="0" algn="ctr">
               <a:buNone/>
             </a:pPr>
             <a:r>
@@ -9649,7 +10490,7 @@
           </a:prstGeom>
           <a:extLst>
             <a:ext uri="{C572A759-6A51-4108-AA02-DFA0A04FC94B}">
-              <ma14:wrappingTextBoxFlag xmlns:ma14="http://schemas.microsoft.com/office/mac/drawingml/2011/main" val="0"/>
+              <ma14:wrappingTextBoxFlag xmlns:ma14="http://schemas.microsoft.com/office/mac/drawingml/2011/main" xmlns="" val="0"/>
             </a:ext>
           </a:extLst>
         </p:spPr>
@@ -9667,7 +10508,7 @@
           <a:p>
             <a:pPr algn="l"/>
             <a:fld id="{F7021451-1387-4CA6-816F-3879F97B5CBC}" type="slidenum">
-              <a:rPr b="0" lang="en-US"/>
+              <a:rPr lang="en-US" b="0"/>
               <a:t>9</a:t>
             </a:fld>
             <a:endParaRPr lang="en-US"/>
@@ -9676,7 +10517,13 @@
       </p:sp>
       <p:pic>
         <p:nvPicPr>
-          <p:cNvPr id="26" name="Picture 25" descr="data_model.jpg"/>
+          <p:cNvPr id="7" name="Picture 6">
+            <a:extLst>
+              <a:ext uri="{FF2B5EF4-FFF2-40B4-BE49-F238E27FC236}">
+                <a16:creationId xmlns:a16="http://schemas.microsoft.com/office/drawing/2014/main" id="{147C40EF-8A04-A83E-B604-ED6EB968887E}"/>
+              </a:ext>
+            </a:extLst>
+          </p:cNvPr>
           <p:cNvPicPr>
             <a:picLocks noChangeAspect="1"/>
           </p:cNvPicPr>
@@ -9690,8 +10537,8 @@
         </p:blipFill>
         <p:spPr>
           <a:xfrm>
-            <a:off x="548640" y="1188720"/>
-            <a:ext cx="8046720" cy="5574463"/>
+            <a:off x="445111" y="571500"/>
+            <a:ext cx="8282329" cy="4356100"/>
           </a:xfrm>
           <a:prstGeom prst="rect">
             <a:avLst/>
@@ -9999,4 +10846,299 @@
     </a:ext>
   </a:extLst>
 </a:theme>
+</file>
+
+<file path=ppt/theme/theme2.xml><?xml version="1.0" encoding="utf-8"?>
+<a:theme xmlns:a="http://schemas.openxmlformats.org/drawingml/2006/main" name="Office Theme">
+  <a:themeElements>
+    <a:clrScheme name="Office">
+      <a:dk1>
+        <a:sysClr val="windowText" lastClr="000000"/>
+      </a:dk1>
+      <a:lt1>
+        <a:sysClr val="window" lastClr="FFFFFF"/>
+      </a:lt1>
+      <a:dk2>
+        <a:srgbClr val="44546A"/>
+      </a:dk2>
+      <a:lt2>
+        <a:srgbClr val="E7E6E6"/>
+      </a:lt2>
+      <a:accent1>
+        <a:srgbClr val="4472C4"/>
+      </a:accent1>
+      <a:accent2>
+        <a:srgbClr val="ED7D31"/>
+      </a:accent2>
+      <a:accent3>
+        <a:srgbClr val="A5A5A5"/>
+      </a:accent3>
+      <a:accent4>
+        <a:srgbClr val="FFC000"/>
+      </a:accent4>
+      <a:accent5>
+        <a:srgbClr val="5B9BD5"/>
+      </a:accent5>
+      <a:accent6>
+        <a:srgbClr val="70AD47"/>
+      </a:accent6>
+      <a:hlink>
+        <a:srgbClr val="0563C1"/>
+      </a:hlink>
+      <a:folHlink>
+        <a:srgbClr val="954F72"/>
+      </a:folHlink>
+    </a:clrScheme>
+    <a:fontScheme name="Office">
+      <a:majorFont>
+        <a:latin typeface="Calibri Light" panose="020F0302020204030204"/>
+        <a:ea typeface=""/>
+        <a:cs typeface=""/>
+        <a:font script="Jpan" typeface="游ゴシック Light"/>
+        <a:font script="Hang" typeface="맑은 고딕"/>
+        <a:font script="Hans" typeface="等线 Light"/>
+        <a:font script="Hant" typeface="新細明體"/>
+        <a:font script="Arab" typeface="Times New Roman"/>
+        <a:font script="Hebr" typeface="Times New Roman"/>
+        <a:font script="Thai" typeface="Angsana New"/>
+        <a:font script="Ethi" typeface="Nyala"/>
+        <a:font script="Beng" typeface="Vrinda"/>
+        <a:font script="Gujr" typeface="Shruti"/>
+        <a:font script="Khmr" typeface="MoolBoran"/>
+        <a:font script="Knda" typeface="Tunga"/>
+        <a:font script="Guru" typeface="Raavi"/>
+        <a:font script="Cans" typeface="Euphemia"/>
+        <a:font script="Cher" typeface="Plantagenet Cherokee"/>
+        <a:font script="Yiii" typeface="Microsoft Yi Baiti"/>
+        <a:font script="Tibt" typeface="Microsoft Himalaya"/>
+        <a:font script="Thaa" typeface="MV Boli"/>
+        <a:font script="Deva" typeface="Mangal"/>
+        <a:font script="Telu" typeface="Gautami"/>
+        <a:font script="Taml" typeface="Latha"/>
+        <a:font script="Syrc" typeface="Estrangelo Edessa"/>
+        <a:font script="Orya" typeface="Kalinga"/>
+        <a:font script="Mlym" typeface="Kartika"/>
+        <a:font script="Laoo" typeface="DokChampa"/>
+        <a:font script="Sinh" typeface="Iskoola Pota"/>
+        <a:font script="Mong" typeface="Mongolian Baiti"/>
+        <a:font script="Viet" typeface="Times New Roman"/>
+        <a:font script="Uigh" typeface="Microsoft Uighur"/>
+        <a:font script="Geor" typeface="Sylfaen"/>
+        <a:font script="Armn" typeface="Arial"/>
+        <a:font script="Bugi" typeface="Leelawadee UI"/>
+        <a:font script="Bopo" typeface="Microsoft JhengHei"/>
+        <a:font script="Java" typeface="Javanese Text"/>
+        <a:font script="Lisu" typeface="Segoe UI"/>
+        <a:font script="Mymr" typeface="Myanmar Text"/>
+        <a:font script="Nkoo" typeface="Ebrima"/>
+        <a:font script="Olck" typeface="Nirmala UI"/>
+        <a:font script="Osma" typeface="Ebrima"/>
+        <a:font script="Phag" typeface="Phagspa"/>
+        <a:font script="Syrn" typeface="Estrangelo Edessa"/>
+        <a:font script="Syrj" typeface="Estrangelo Edessa"/>
+        <a:font script="Syre" typeface="Estrangelo Edessa"/>
+        <a:font script="Sora" typeface="Nirmala UI"/>
+        <a:font script="Tale" typeface="Microsoft Tai Le"/>
+        <a:font script="Talu" typeface="Microsoft New Tai Lue"/>
+        <a:font script="Tfng" typeface="Ebrima"/>
+      </a:majorFont>
+      <a:minorFont>
+        <a:latin typeface="Calibri" panose="020F0502020204030204"/>
+        <a:ea typeface=""/>
+        <a:cs typeface=""/>
+        <a:font script="Jpan" typeface="游ゴシック"/>
+        <a:font script="Hang" typeface="맑은 고딕"/>
+        <a:font script="Hans" typeface="等线"/>
+        <a:font script="Hant" typeface="新細明體"/>
+        <a:font script="Arab" typeface="Arial"/>
+        <a:font script="Hebr" typeface="Arial"/>
+        <a:font script="Thai" typeface="Cordia New"/>
+        <a:font script="Ethi" typeface="Nyala"/>
+        <a:font script="Beng" typeface="Vrinda"/>
+        <a:font script="Gujr" typeface="Shruti"/>
+        <a:font script="Khmr" typeface="DaunPenh"/>
+        <a:font script="Knda" typeface="Tunga"/>
+        <a:font script="Guru" typeface="Raavi"/>
+        <a:font script="Cans" typeface="Euphemia"/>
+        <a:font script="Cher" typeface="Plantagenet Cherokee"/>
+        <a:font script="Yiii" typeface="Microsoft Yi Baiti"/>
+        <a:font script="Tibt" typeface="Microsoft Himalaya"/>
+        <a:font script="Thaa" typeface="MV Boli"/>
+        <a:font script="Deva" typeface="Mangal"/>
+        <a:font script="Telu" typeface="Gautami"/>
+        <a:font script="Taml" typeface="Latha"/>
+        <a:font script="Syrc" typeface="Estrangelo Edessa"/>
+        <a:font script="Orya" typeface="Kalinga"/>
+        <a:font script="Mlym" typeface="Kartika"/>
+        <a:font script="Laoo" typeface="DokChampa"/>
+        <a:font script="Sinh" typeface="Iskoola Pota"/>
+        <a:font script="Mong" typeface="Mongolian Baiti"/>
+        <a:font script="Viet" typeface="Arial"/>
+        <a:font script="Uigh" typeface="Microsoft Uighur"/>
+        <a:font script="Geor" typeface="Sylfaen"/>
+        <a:font script="Armn" typeface="Arial"/>
+        <a:font script="Bugi" typeface="Leelawadee UI"/>
+        <a:font script="Bopo" typeface="Microsoft JhengHei"/>
+        <a:font script="Java" typeface="Javanese Text"/>
+        <a:font script="Lisu" typeface="Segoe UI"/>
+        <a:font script="Mymr" typeface="Myanmar Text"/>
+        <a:font script="Nkoo" typeface="Ebrima"/>
+        <a:font script="Olck" typeface="Nirmala UI"/>
+        <a:font script="Osma" typeface="Ebrima"/>
+        <a:font script="Phag" typeface="Phagspa"/>
+        <a:font script="Syrn" typeface="Estrangelo Edessa"/>
+        <a:font script="Syrj" typeface="Estrangelo Edessa"/>
+        <a:font script="Syre" typeface="Estrangelo Edessa"/>
+        <a:font script="Sora" typeface="Nirmala UI"/>
+        <a:font script="Tale" typeface="Microsoft Tai Le"/>
+        <a:font script="Talu" typeface="Microsoft New Tai Lue"/>
+        <a:font script="Tfng" typeface="Ebrima"/>
+      </a:minorFont>
+    </a:fontScheme>
+    <a:fmtScheme name="Office">
+      <a:fillStyleLst>
+        <a:solidFill>
+          <a:schemeClr val="phClr"/>
+        </a:solidFill>
+        <a:gradFill rotWithShape="1">
+          <a:gsLst>
+            <a:gs pos="0">
+              <a:schemeClr val="phClr">
+                <a:lumMod val="110000"/>
+                <a:satMod val="105000"/>
+                <a:tint val="67000"/>
+              </a:schemeClr>
+            </a:gs>
+            <a:gs pos="50000">
+              <a:schemeClr val="phClr">
+                <a:lumMod val="105000"/>
+                <a:satMod val="103000"/>
+                <a:tint val="73000"/>
+              </a:schemeClr>
+            </a:gs>
+            <a:gs pos="100000">
+              <a:schemeClr val="phClr">
+                <a:lumMod val="105000"/>
+                <a:satMod val="109000"/>
+                <a:tint val="81000"/>
+              </a:schemeClr>
+            </a:gs>
+          </a:gsLst>
+          <a:lin ang="5400000" scaled="0"/>
+        </a:gradFill>
+        <a:gradFill rotWithShape="1">
+          <a:gsLst>
+            <a:gs pos="0">
+              <a:schemeClr val="phClr">
+                <a:satMod val="103000"/>
+                <a:lumMod val="102000"/>
+                <a:tint val="94000"/>
+              </a:schemeClr>
+            </a:gs>
+            <a:gs pos="50000">
+              <a:schemeClr val="phClr">
+                <a:satMod val="110000"/>
+                <a:lumMod val="100000"/>
+                <a:shade val="100000"/>
+              </a:schemeClr>
+            </a:gs>
+            <a:gs pos="100000">
+              <a:schemeClr val="phClr">
+                <a:lumMod val="99000"/>
+                <a:satMod val="120000"/>
+                <a:shade val="78000"/>
+              </a:schemeClr>
+            </a:gs>
+          </a:gsLst>
+          <a:lin ang="5400000" scaled="0"/>
+        </a:gradFill>
+      </a:fillStyleLst>
+      <a:lnStyleLst>
+        <a:ln w="6350" cap="flat" cmpd="sng" algn="ctr">
+          <a:solidFill>
+            <a:schemeClr val="phClr"/>
+          </a:solidFill>
+          <a:prstDash val="solid"/>
+          <a:miter lim="800000"/>
+        </a:ln>
+        <a:ln w="12700" cap="flat" cmpd="sng" algn="ctr">
+          <a:solidFill>
+            <a:schemeClr val="phClr"/>
+          </a:solidFill>
+          <a:prstDash val="solid"/>
+          <a:miter lim="800000"/>
+        </a:ln>
+        <a:ln w="19050" cap="flat" cmpd="sng" algn="ctr">
+          <a:solidFill>
+            <a:schemeClr val="phClr"/>
+          </a:solidFill>
+          <a:prstDash val="solid"/>
+          <a:miter lim="800000"/>
+        </a:ln>
+      </a:lnStyleLst>
+      <a:effectStyleLst>
+        <a:effectStyle>
+          <a:effectLst/>
+        </a:effectStyle>
+        <a:effectStyle>
+          <a:effectLst/>
+        </a:effectStyle>
+        <a:effectStyle>
+          <a:effectLst>
+            <a:outerShdw blurRad="57150" dist="19050" dir="5400000" algn="ctr" rotWithShape="0">
+              <a:srgbClr val="000000">
+                <a:alpha val="63000"/>
+              </a:srgbClr>
+            </a:outerShdw>
+          </a:effectLst>
+        </a:effectStyle>
+      </a:effectStyleLst>
+      <a:bgFillStyleLst>
+        <a:solidFill>
+          <a:schemeClr val="phClr"/>
+        </a:solidFill>
+        <a:solidFill>
+          <a:schemeClr val="phClr">
+            <a:tint val="95000"/>
+            <a:satMod val="170000"/>
+          </a:schemeClr>
+        </a:solidFill>
+        <a:gradFill rotWithShape="1">
+          <a:gsLst>
+            <a:gs pos="0">
+              <a:schemeClr val="phClr">
+                <a:tint val="93000"/>
+                <a:satMod val="150000"/>
+                <a:shade val="98000"/>
+                <a:lumMod val="102000"/>
+              </a:schemeClr>
+            </a:gs>
+            <a:gs pos="50000">
+              <a:schemeClr val="phClr">
+                <a:tint val="98000"/>
+                <a:satMod val="130000"/>
+                <a:shade val="90000"/>
+                <a:lumMod val="103000"/>
+              </a:schemeClr>
+            </a:gs>
+            <a:gs pos="100000">
+              <a:schemeClr val="phClr">
+                <a:shade val="63000"/>
+                <a:satMod val="120000"/>
+              </a:schemeClr>
+            </a:gs>
+          </a:gsLst>
+          <a:lin ang="5400000" scaled="0"/>
+        </a:gradFill>
+      </a:bgFillStyleLst>
+    </a:fmtScheme>
+  </a:themeElements>
+  <a:objectDefaults/>
+  <a:extraClrSchemeLst/>
+  <a:extLst>
+    <a:ext uri="{05A4C25C-085E-4340-85A3-A5531E510DB2}">
+      <thm15:themeFamily xmlns:thm15="http://schemas.microsoft.com/office/thememl/2012/main" name="Office Theme" id="{62F939B6-93AF-4DB8-9C6B-D6C7DFDC589F}" vid="{4A3C46E8-61CC-4603-A589-7422A47A8E4A}"/>
+    </a:ext>
+  </a:extLst>
+</a:theme>
 </file>
</xml_diff>